<commit_message>
Refine mini app hands-on prompt
</commit_message>
<xml_diff>
--- a/slides/seminar.pptx
+++ b/slides/seminar.pptx
@@ -10742,7 +10742,7 @@
                 <a:ea typeface="Menlo" pitchFamily="34" charset="-122"/>
                 <a:cs typeface="Menlo" pitchFamily="34" charset="-120"/>
               </a:rPr>
-              <a:t>&gt; ToDoアプリを作って</a:t>
+              <a:t>&gt; ミニToDoアプリを作って</a:t>
             </a:r>
             <a:endParaRPr lang="en-US" sz="1250" dirty="0"/>
           </a:p>
@@ -10822,7 +10822,7 @@
                 <a:ea typeface="Menlo" pitchFamily="34" charset="-122"/>
                 <a:cs typeface="Menlo" pitchFamily="34" charset="-120"/>
               </a:rPr>
-              <a:t>  + styles.css</a:t>
+              <a:t>  ✓ ブラウザで表示確認</a:t>
             </a:r>
             <a:endParaRPr lang="en-US" sz="1250" dirty="0"/>
           </a:p>
@@ -10842,7 +10842,7 @@
                 <a:ea typeface="Menlo" pitchFamily="34" charset="-122"/>
                 <a:cs typeface="Menlo" pitchFamily="34" charset="-120"/>
               </a:rPr>
-              <a:t>  + src/storage.js</a:t>
+              <a:t>  ✓ 追加・完了・削除を確認</a:t>
             </a:r>
             <a:endParaRPr lang="en-US" sz="1250" dirty="0"/>
           </a:p>
@@ -10856,13 +10856,13 @@
             <a:r>
               <a:rPr lang="en-US" sz="1250" dirty="0">
                 <a:solidFill>
-                  <a:srgbClr val="3FB950"/>
+                  <a:srgbClr val="C9D1D9"/>
                 </a:solidFill>
                 <a:latin typeface="Menlo" pitchFamily="34" charset="0"/>
                 <a:ea typeface="Menlo" pitchFamily="34" charset="-122"/>
                 <a:cs typeface="Menlo" pitchFamily="34" charset="-120"/>
               </a:rPr>
-              <a:t>  + src/todo.js</a:t>
+              <a:t> </a:t>
             </a:r>
             <a:endParaRPr lang="en-US" sz="1250" dirty="0"/>
           </a:p>
@@ -10882,47 +10882,7 @@
                 <a:ea typeface="Menlo" pitchFamily="34" charset="-122"/>
                 <a:cs typeface="Menlo" pitchFamily="34" charset="-120"/>
               </a:rPr>
-              <a:t>  + src/app.js</a:t>
-            </a:r>
-            <a:endParaRPr lang="en-US" sz="1250" dirty="0"/>
-          </a:p>
-          <a:p>
-            <a:pPr algn="l" indent="0" marL="0">
-              <a:lnSpc>
-                <a:spcPct val="125000"/>
-              </a:lnSpc>
-              <a:buNone/>
-            </a:pPr>
-            <a:r>
-              <a:rPr lang="en-US" sz="1250" dirty="0">
-                <a:solidFill>
-                  <a:srgbClr val="C9D1D9"/>
-                </a:solidFill>
-                <a:latin typeface="Menlo" pitchFamily="34" charset="0"/>
-                <a:ea typeface="Menlo" pitchFamily="34" charset="-122"/>
-                <a:cs typeface="Menlo" pitchFamily="34" charset="-120"/>
-              </a:rPr>
-              <a:t> </a:t>
-            </a:r>
-            <a:endParaRPr lang="en-US" sz="1250" dirty="0"/>
-          </a:p>
-          <a:p>
-            <a:pPr algn="l" indent="0" marL="0">
-              <a:lnSpc>
-                <a:spcPct val="125000"/>
-              </a:lnSpc>
-              <a:buNone/>
-            </a:pPr>
-            <a:r>
-              <a:rPr lang="en-US" sz="1250" dirty="0">
-                <a:solidFill>
-                  <a:srgbClr val="3FB950"/>
-                </a:solidFill>
-                <a:latin typeface="Menlo" pitchFamily="34" charset="0"/>
-                <a:ea typeface="Menlo" pitchFamily="34" charset="-122"/>
-                <a:cs typeface="Menlo" pitchFamily="34" charset="-120"/>
-              </a:rPr>
-              <a:t>  ✓ 5ファイル作成</a:t>
+              <a:t>  ✓ 1ファイル作成</a:t>
             </a:r>
             <a:endParaRPr lang="en-US" sz="1250" dirty="0"/>
           </a:p>
@@ -11163,7 +11123,7 @@
                 <a:ea typeface="Hiragino Sans" pitchFamily="34" charset="-122"/>
                 <a:cs typeface="Hiragino Sans" pitchFamily="34" charset="-120"/>
               </a:rPr>
-              <a:t>STEP 6 ── ToDoアプリを作る</a:t>
+              <a:t>STEP 6 ── 作るものを決める</a:t>
             </a:r>
             <a:endParaRPr lang="en-US" sz="2900" dirty="0"/>
           </a:p>
@@ -11171,18 +11131,585 @@
       </p:sp>
       <p:sp>
         <p:nvSpPr>
-          <p:cNvPr id="5" name="Shape 3"/>
-          <p:cNvSpPr/>
-          <p:nvPr/>
-        </p:nvSpPr>
-        <p:spPr>
-          <a:xfrm>
-            <a:off x="640080" y="1920240"/>
-            <a:ext cx="5669280" cy="3886200"/>
+          <p:cNvPr id="5" name="Text 3"/>
+          <p:cNvSpPr/>
+          <p:nvPr/>
+        </p:nvSpPr>
+        <p:spPr>
+          <a:xfrm>
+            <a:off x="640080" y="1737360"/>
+            <a:ext cx="10908792" cy="411480"/>
+          </a:xfrm>
+          <a:prstGeom prst="rect">
+            <a:avLst/>
+          </a:prstGeom>
+          <a:noFill/>
+          <a:ln/>
+        </p:spPr>
+        <p:txBody>
+          <a:bodyPr wrap="square" lIns="0" tIns="0" rIns="0" bIns="0" rtlCol="0" anchor="ctr"/>
+          <a:lstStyle/>
+          <a:p>
+            <a:pPr algn="l" indent="0" marL="0">
+              <a:buNone/>
+            </a:pPr>
+            <a:r>
+              <a:rPr lang="en-US" sz="1600" dirty="0">
+                <a:solidFill>
+                  <a:srgbClr val="C9D1D9"/>
+                </a:solidFill>
+                <a:latin typeface="Hiragino Sans" pitchFamily="34" charset="0"/>
+                <a:ea typeface="Hiragino Sans" pitchFamily="34" charset="-122"/>
+                <a:cs typeface="Hiragino Sans" pitchFamily="34" charset="-120"/>
+              </a:rPr>
+              <a:t>今日は、ブラウザだけで動く ToDo ミニアプリを作ります。</a:t>
+            </a:r>
+            <a:endParaRPr lang="en-US" sz="1600" dirty="0"/>
+          </a:p>
+        </p:txBody>
+      </p:sp>
+      <p:sp>
+        <p:nvSpPr>
+          <p:cNvPr id="6" name="Shape 4"/>
+          <p:cNvSpPr/>
+          <p:nvPr/>
+        </p:nvSpPr>
+        <p:spPr>
+          <a:xfrm>
+            <a:off x="640080" y="2423160"/>
+            <a:ext cx="4572000" cy="749808"/>
           </a:xfrm>
           <a:prstGeom prst="roundRect">
             <a:avLst>
-              <a:gd name="adj" fmla="val 1412"/>
+              <a:gd name="adj" fmla="val 9756"/>
+            </a:avLst>
+          </a:prstGeom>
+          <a:solidFill>
+            <a:srgbClr val="161B22"/>
+          </a:solidFill>
+          <a:ln w="12700">
+            <a:solidFill>
+              <a:srgbClr val="30363D"/>
+            </a:solidFill>
+            <a:prstDash val="solid"/>
+          </a:ln>
+          <a:effectLst>
+            <a:outerShdw sx="100000" sy="100000" kx="0" ky="0" algn="bl" rotWithShape="0" blurRad="127000" dist="38100" dir="5400000">
+              <a:srgbClr val="000000">
+                <a:alpha val="35000"/>
+              </a:srgbClr>
+            </a:outerShdw>
+          </a:effectLst>
+        </p:spPr>
+      </p:sp>
+      <p:sp>
+        <p:nvSpPr>
+          <p:cNvPr id="7" name="Shape 5"/>
+          <p:cNvSpPr/>
+          <p:nvPr/>
+        </p:nvSpPr>
+        <p:spPr>
+          <a:xfrm>
+            <a:off x="640080" y="2423160"/>
+            <a:ext cx="82296" cy="749808"/>
+          </a:xfrm>
+          <a:prstGeom prst="rect">
+            <a:avLst/>
+          </a:prstGeom>
+          <a:solidFill>
+            <a:srgbClr val="3FB950"/>
+          </a:solidFill>
+          <a:ln/>
+        </p:spPr>
+      </p:sp>
+      <p:sp>
+        <p:nvSpPr>
+          <p:cNvPr id="8" name="Text 6"/>
+          <p:cNvSpPr/>
+          <p:nvPr/>
+        </p:nvSpPr>
+        <p:spPr>
+          <a:xfrm>
+            <a:off x="1005840" y="2514600"/>
+            <a:ext cx="3931920" cy="365760"/>
+          </a:xfrm>
+          <a:prstGeom prst="rect">
+            <a:avLst/>
+          </a:prstGeom>
+          <a:noFill/>
+          <a:ln/>
+        </p:spPr>
+        <p:txBody>
+          <a:bodyPr wrap="square" lIns="0" tIns="0" rIns="0" bIns="0" rtlCol="0" anchor="ctr"/>
+          <a:lstStyle/>
+          <a:p>
+            <a:pPr algn="l" indent="0" marL="0">
+              <a:buNone/>
+            </a:pPr>
+            <a:r>
+              <a:rPr lang="en-US" sz="1600" b="1" dirty="0">
+                <a:solidFill>
+                  <a:srgbClr val="E6EDF3"/>
+                </a:solidFill>
+                <a:latin typeface="Hiragino Sans" pitchFamily="34" charset="0"/>
+                <a:ea typeface="Hiragino Sans" pitchFamily="34" charset="-122"/>
+                <a:cs typeface="Hiragino Sans" pitchFamily="34" charset="-120"/>
+              </a:rPr>
+              <a:t>追加・完了・削除</a:t>
+            </a:r>
+            <a:endParaRPr lang="en-US" sz="1600" dirty="0"/>
+          </a:p>
+        </p:txBody>
+      </p:sp>
+      <p:sp>
+        <p:nvSpPr>
+          <p:cNvPr id="9" name="Text 7"/>
+          <p:cNvSpPr/>
+          <p:nvPr/>
+        </p:nvSpPr>
+        <p:spPr>
+          <a:xfrm>
+            <a:off x="1005840" y="2862072"/>
+            <a:ext cx="3931920" cy="292608"/>
+          </a:xfrm>
+          <a:prstGeom prst="rect">
+            <a:avLst/>
+          </a:prstGeom>
+          <a:noFill/>
+          <a:ln/>
+        </p:spPr>
+        <p:txBody>
+          <a:bodyPr wrap="square" lIns="0" tIns="0" rIns="0" bIns="0" rtlCol="0" anchor="ctr"/>
+          <a:lstStyle/>
+          <a:p>
+            <a:pPr algn="l" indent="0" marL="0">
+              <a:buNone/>
+            </a:pPr>
+            <a:r>
+              <a:rPr lang="en-US" sz="1250" dirty="0">
+                <a:solidFill>
+                  <a:srgbClr val="8B949E"/>
+                </a:solidFill>
+                <a:latin typeface="Hiragino Sans" pitchFamily="34" charset="0"/>
+                <a:ea typeface="Hiragino Sans" pitchFamily="34" charset="-122"/>
+                <a:cs typeface="Hiragino Sans" pitchFamily="34" charset="-120"/>
+              </a:rPr>
+              <a:t>基本操作がその場で試せる</a:t>
+            </a:r>
+            <a:endParaRPr lang="en-US" sz="1250" dirty="0"/>
+          </a:p>
+        </p:txBody>
+      </p:sp>
+      <p:sp>
+        <p:nvSpPr>
+          <p:cNvPr id="10" name="Shape 8"/>
+          <p:cNvSpPr/>
+          <p:nvPr/>
+        </p:nvSpPr>
+        <p:spPr>
+          <a:xfrm>
+            <a:off x="640080" y="3300984"/>
+            <a:ext cx="4572000" cy="749808"/>
+          </a:xfrm>
+          <a:prstGeom prst="roundRect">
+            <a:avLst>
+              <a:gd name="adj" fmla="val 9756"/>
+            </a:avLst>
+          </a:prstGeom>
+          <a:solidFill>
+            <a:srgbClr val="161B22"/>
+          </a:solidFill>
+          <a:ln w="12700">
+            <a:solidFill>
+              <a:srgbClr val="30363D"/>
+            </a:solidFill>
+            <a:prstDash val="solid"/>
+          </a:ln>
+          <a:effectLst>
+            <a:outerShdw sx="100000" sy="100000" kx="0" ky="0" algn="bl" rotWithShape="0" blurRad="127000" dist="38100" dir="5400000">
+              <a:srgbClr val="000000">
+                <a:alpha val="35000"/>
+              </a:srgbClr>
+            </a:outerShdw>
+          </a:effectLst>
+        </p:spPr>
+      </p:sp>
+      <p:sp>
+        <p:nvSpPr>
+          <p:cNvPr id="11" name="Shape 9"/>
+          <p:cNvSpPr/>
+          <p:nvPr/>
+        </p:nvSpPr>
+        <p:spPr>
+          <a:xfrm>
+            <a:off x="640080" y="3300984"/>
+            <a:ext cx="82296" cy="749808"/>
+          </a:xfrm>
+          <a:prstGeom prst="rect">
+            <a:avLst/>
+          </a:prstGeom>
+          <a:solidFill>
+            <a:srgbClr val="58A6FF"/>
+          </a:solidFill>
+          <a:ln/>
+        </p:spPr>
+      </p:sp>
+      <p:sp>
+        <p:nvSpPr>
+          <p:cNvPr id="12" name="Text 10"/>
+          <p:cNvSpPr/>
+          <p:nvPr/>
+        </p:nvSpPr>
+        <p:spPr>
+          <a:xfrm>
+            <a:off x="1005840" y="3392424"/>
+            <a:ext cx="3931920" cy="365760"/>
+          </a:xfrm>
+          <a:prstGeom prst="rect">
+            <a:avLst/>
+          </a:prstGeom>
+          <a:noFill/>
+          <a:ln/>
+        </p:spPr>
+        <p:txBody>
+          <a:bodyPr wrap="square" lIns="0" tIns="0" rIns="0" bIns="0" rtlCol="0" anchor="ctr"/>
+          <a:lstStyle/>
+          <a:p>
+            <a:pPr algn="l" indent="0" marL="0">
+              <a:buNone/>
+            </a:pPr>
+            <a:r>
+              <a:rPr lang="en-US" sz="1600" b="1" dirty="0">
+                <a:solidFill>
+                  <a:srgbClr val="E6EDF3"/>
+                </a:solidFill>
+                <a:latin typeface="Hiragino Sans" pitchFamily="34" charset="0"/>
+                <a:ea typeface="Hiragino Sans" pitchFamily="34" charset="-122"/>
+                <a:cs typeface="Hiragino Sans" pitchFamily="34" charset="-120"/>
+              </a:rPr>
+              <a:t>件数が見える</a:t>
+            </a:r>
+            <a:endParaRPr lang="en-US" sz="1600" dirty="0"/>
+          </a:p>
+        </p:txBody>
+      </p:sp>
+      <p:sp>
+        <p:nvSpPr>
+          <p:cNvPr id="13" name="Text 11"/>
+          <p:cNvSpPr/>
+          <p:nvPr/>
+        </p:nvSpPr>
+        <p:spPr>
+          <a:xfrm>
+            <a:off x="1005840" y="3739896"/>
+            <a:ext cx="3931920" cy="292608"/>
+          </a:xfrm>
+          <a:prstGeom prst="rect">
+            <a:avLst/>
+          </a:prstGeom>
+          <a:noFill/>
+          <a:ln/>
+        </p:spPr>
+        <p:txBody>
+          <a:bodyPr wrap="square" lIns="0" tIns="0" rIns="0" bIns="0" rtlCol="0" anchor="ctr"/>
+          <a:lstStyle/>
+          <a:p>
+            <a:pPr algn="l" indent="0" marL="0">
+              <a:buNone/>
+            </a:pPr>
+            <a:r>
+              <a:rPr lang="en-US" sz="1250" dirty="0">
+                <a:solidFill>
+                  <a:srgbClr val="8B949E"/>
+                </a:solidFill>
+                <a:latin typeface="Hiragino Sans" pitchFamily="34" charset="0"/>
+                <a:ea typeface="Hiragino Sans" pitchFamily="34" charset="-122"/>
+                <a:cs typeface="Hiragino Sans" pitchFamily="34" charset="-120"/>
+              </a:rPr>
+              <a:t>残り件数と完了件数を表示</a:t>
+            </a:r>
+            <a:endParaRPr lang="en-US" sz="1250" dirty="0"/>
+          </a:p>
+        </p:txBody>
+      </p:sp>
+      <p:sp>
+        <p:nvSpPr>
+          <p:cNvPr id="14" name="Shape 12"/>
+          <p:cNvSpPr/>
+          <p:nvPr/>
+        </p:nvSpPr>
+        <p:spPr>
+          <a:xfrm>
+            <a:off x="640080" y="4178808"/>
+            <a:ext cx="4572000" cy="749808"/>
+          </a:xfrm>
+          <a:prstGeom prst="roundRect">
+            <a:avLst>
+              <a:gd name="adj" fmla="val 9756"/>
+            </a:avLst>
+          </a:prstGeom>
+          <a:solidFill>
+            <a:srgbClr val="161B22"/>
+          </a:solidFill>
+          <a:ln w="12700">
+            <a:solidFill>
+              <a:srgbClr val="30363D"/>
+            </a:solidFill>
+            <a:prstDash val="solid"/>
+          </a:ln>
+          <a:effectLst>
+            <a:outerShdw sx="100000" sy="100000" kx="0" ky="0" algn="bl" rotWithShape="0" blurRad="127000" dist="38100" dir="5400000">
+              <a:srgbClr val="000000">
+                <a:alpha val="35000"/>
+              </a:srgbClr>
+            </a:outerShdw>
+          </a:effectLst>
+        </p:spPr>
+      </p:sp>
+      <p:sp>
+        <p:nvSpPr>
+          <p:cNvPr id="15" name="Shape 13"/>
+          <p:cNvSpPr/>
+          <p:nvPr/>
+        </p:nvSpPr>
+        <p:spPr>
+          <a:xfrm>
+            <a:off x="640080" y="4178808"/>
+            <a:ext cx="82296" cy="749808"/>
+          </a:xfrm>
+          <a:prstGeom prst="rect">
+            <a:avLst/>
+          </a:prstGeom>
+          <a:solidFill>
+            <a:srgbClr val="BC8CFF"/>
+          </a:solidFill>
+          <a:ln/>
+        </p:spPr>
+      </p:sp>
+      <p:sp>
+        <p:nvSpPr>
+          <p:cNvPr id="16" name="Text 14"/>
+          <p:cNvSpPr/>
+          <p:nvPr/>
+        </p:nvSpPr>
+        <p:spPr>
+          <a:xfrm>
+            <a:off x="1005840" y="4270248"/>
+            <a:ext cx="3931920" cy="365760"/>
+          </a:xfrm>
+          <a:prstGeom prst="rect">
+            <a:avLst/>
+          </a:prstGeom>
+          <a:noFill/>
+          <a:ln/>
+        </p:spPr>
+        <p:txBody>
+          <a:bodyPr wrap="square" lIns="0" tIns="0" rIns="0" bIns="0" rtlCol="0" anchor="ctr"/>
+          <a:lstStyle/>
+          <a:p>
+            <a:pPr algn="l" indent="0" marL="0">
+              <a:buNone/>
+            </a:pPr>
+            <a:r>
+              <a:rPr lang="en-US" sz="1600" b="1" dirty="0">
+                <a:solidFill>
+                  <a:srgbClr val="E6EDF3"/>
+                </a:solidFill>
+                <a:latin typeface="Hiragino Sans" pitchFamily="34" charset="0"/>
+                <a:ea typeface="Hiragino Sans" pitchFamily="34" charset="-122"/>
+                <a:cs typeface="Hiragino Sans" pitchFamily="34" charset="-120"/>
+              </a:rPr>
+              <a:t>閉じても残る</a:t>
+            </a:r>
+            <a:endParaRPr lang="en-US" sz="1600" dirty="0"/>
+          </a:p>
+        </p:txBody>
+      </p:sp>
+      <p:sp>
+        <p:nvSpPr>
+          <p:cNvPr id="17" name="Text 15"/>
+          <p:cNvSpPr/>
+          <p:nvPr/>
+        </p:nvSpPr>
+        <p:spPr>
+          <a:xfrm>
+            <a:off x="1005840" y="4617720"/>
+            <a:ext cx="3931920" cy="292608"/>
+          </a:xfrm>
+          <a:prstGeom prst="rect">
+            <a:avLst/>
+          </a:prstGeom>
+          <a:noFill/>
+          <a:ln/>
+        </p:spPr>
+        <p:txBody>
+          <a:bodyPr wrap="square" lIns="0" tIns="0" rIns="0" bIns="0" rtlCol="0" anchor="ctr"/>
+          <a:lstStyle/>
+          <a:p>
+            <a:pPr algn="l" indent="0" marL="0">
+              <a:buNone/>
+            </a:pPr>
+            <a:r>
+              <a:rPr lang="en-US" sz="1250" dirty="0">
+                <a:solidFill>
+                  <a:srgbClr val="8B949E"/>
+                </a:solidFill>
+                <a:latin typeface="Hiragino Sans" pitchFamily="34" charset="0"/>
+                <a:ea typeface="Hiragino Sans" pitchFamily="34" charset="-122"/>
+                <a:cs typeface="Hiragino Sans" pitchFamily="34" charset="-120"/>
+              </a:rPr>
+              <a:t>localStorage に保存</a:t>
+            </a:r>
+            <a:endParaRPr lang="en-US" sz="1250" dirty="0"/>
+          </a:p>
+        </p:txBody>
+      </p:sp>
+      <p:sp>
+        <p:nvSpPr>
+          <p:cNvPr id="18" name="Shape 16"/>
+          <p:cNvSpPr/>
+          <p:nvPr/>
+        </p:nvSpPr>
+        <p:spPr>
+          <a:xfrm>
+            <a:off x="640080" y="5056632"/>
+            <a:ext cx="4572000" cy="749808"/>
+          </a:xfrm>
+          <a:prstGeom prst="roundRect">
+            <a:avLst>
+              <a:gd name="adj" fmla="val 9756"/>
+            </a:avLst>
+          </a:prstGeom>
+          <a:solidFill>
+            <a:srgbClr val="161B22"/>
+          </a:solidFill>
+          <a:ln w="12700">
+            <a:solidFill>
+              <a:srgbClr val="30363D"/>
+            </a:solidFill>
+            <a:prstDash val="solid"/>
+          </a:ln>
+          <a:effectLst>
+            <a:outerShdw sx="100000" sy="100000" kx="0" ky="0" algn="bl" rotWithShape="0" blurRad="127000" dist="38100" dir="5400000">
+              <a:srgbClr val="000000">
+                <a:alpha val="35000"/>
+              </a:srgbClr>
+            </a:outerShdw>
+          </a:effectLst>
+        </p:spPr>
+      </p:sp>
+      <p:sp>
+        <p:nvSpPr>
+          <p:cNvPr id="19" name="Shape 17"/>
+          <p:cNvSpPr/>
+          <p:nvPr/>
+        </p:nvSpPr>
+        <p:spPr>
+          <a:xfrm>
+            <a:off x="640080" y="5056632"/>
+            <a:ext cx="82296" cy="749808"/>
+          </a:xfrm>
+          <a:prstGeom prst="rect">
+            <a:avLst/>
+          </a:prstGeom>
+          <a:solidFill>
+            <a:srgbClr val="F0883E"/>
+          </a:solidFill>
+          <a:ln/>
+        </p:spPr>
+      </p:sp>
+      <p:sp>
+        <p:nvSpPr>
+          <p:cNvPr id="20" name="Text 18"/>
+          <p:cNvSpPr/>
+          <p:nvPr/>
+        </p:nvSpPr>
+        <p:spPr>
+          <a:xfrm>
+            <a:off x="1005840" y="5148072"/>
+            <a:ext cx="3931920" cy="365760"/>
+          </a:xfrm>
+          <a:prstGeom prst="rect">
+            <a:avLst/>
+          </a:prstGeom>
+          <a:noFill/>
+          <a:ln/>
+        </p:spPr>
+        <p:txBody>
+          <a:bodyPr wrap="square" lIns="0" tIns="0" rIns="0" bIns="0" rtlCol="0" anchor="ctr"/>
+          <a:lstStyle/>
+          <a:p>
+            <a:pPr algn="l" indent="0" marL="0">
+              <a:buNone/>
+            </a:pPr>
+            <a:r>
+              <a:rPr lang="en-US" sz="1600" b="1" dirty="0">
+                <a:solidFill>
+                  <a:srgbClr val="E6EDF3"/>
+                </a:solidFill>
+                <a:latin typeface="Hiragino Sans" pitchFamily="34" charset="0"/>
+                <a:ea typeface="Hiragino Sans" pitchFamily="34" charset="-122"/>
+                <a:cs typeface="Hiragino Sans" pitchFamily="34" charset="-120"/>
+              </a:rPr>
+              <a:t>1ファイルで完結</a:t>
+            </a:r>
+            <a:endParaRPr lang="en-US" sz="1600" dirty="0"/>
+          </a:p>
+        </p:txBody>
+      </p:sp>
+      <p:sp>
+        <p:nvSpPr>
+          <p:cNvPr id="21" name="Text 19"/>
+          <p:cNvSpPr/>
+          <p:nvPr/>
+        </p:nvSpPr>
+        <p:spPr>
+          <a:xfrm>
+            <a:off x="1005840" y="5495544"/>
+            <a:ext cx="3931920" cy="292608"/>
+          </a:xfrm>
+          <a:prstGeom prst="rect">
+            <a:avLst/>
+          </a:prstGeom>
+          <a:noFill/>
+          <a:ln/>
+        </p:spPr>
+        <p:txBody>
+          <a:bodyPr wrap="square" lIns="0" tIns="0" rIns="0" bIns="0" rtlCol="0" anchor="ctr"/>
+          <a:lstStyle/>
+          <a:p>
+            <a:pPr algn="l" indent="0" marL="0">
+              <a:buNone/>
+            </a:pPr>
+            <a:r>
+              <a:rPr lang="en-US" sz="1250" dirty="0">
+                <a:solidFill>
+                  <a:srgbClr val="8B949E"/>
+                </a:solidFill>
+                <a:latin typeface="Hiragino Sans" pitchFamily="34" charset="0"/>
+                <a:ea typeface="Hiragino Sans" pitchFamily="34" charset="-122"/>
+                <a:cs typeface="Hiragino Sans" pitchFamily="34" charset="-120"/>
+              </a:rPr>
+              <a:t>index.html だけで配布しやすい</a:t>
+            </a:r>
+            <a:endParaRPr lang="en-US" sz="1250" dirty="0"/>
+          </a:p>
+        </p:txBody>
+      </p:sp>
+      <p:sp>
+        <p:nvSpPr>
+          <p:cNvPr id="22" name="Shape 20"/>
+          <p:cNvSpPr/>
+          <p:nvPr/>
+        </p:nvSpPr>
+        <p:spPr>
+          <a:xfrm>
+            <a:off x="5577840" y="2331720"/>
+            <a:ext cx="5989320" cy="3520440"/>
+          </a:xfrm>
+          <a:prstGeom prst="roundRect">
+            <a:avLst>
+              <a:gd name="adj" fmla="val 2078"/>
             </a:avLst>
           </a:prstGeom>
           <a:solidFill>
@@ -11205,14 +11732,14 @@
       </p:sp>
       <p:sp>
         <p:nvSpPr>
-          <p:cNvPr id="6" name="Shape 4"/>
-          <p:cNvSpPr/>
-          <p:nvPr/>
-        </p:nvSpPr>
-        <p:spPr>
-          <a:xfrm>
-            <a:off x="649224" y="1929384"/>
-            <a:ext cx="5650992" cy="347472"/>
+          <p:cNvPr id="23" name="Shape 21"/>
+          <p:cNvSpPr/>
+          <p:nvPr/>
+        </p:nvSpPr>
+        <p:spPr>
+          <a:xfrm>
+            <a:off x="5577840" y="2331720"/>
+            <a:ext cx="5989320" cy="384048"/>
           </a:xfrm>
           <a:prstGeom prst="rect">
             <a:avLst/>
@@ -11225,13 +11752,13 @@
       </p:sp>
       <p:sp>
         <p:nvSpPr>
-          <p:cNvPr id="7" name="Shape 5"/>
-          <p:cNvSpPr/>
-          <p:nvPr/>
-        </p:nvSpPr>
-        <p:spPr>
-          <a:xfrm>
-            <a:off x="804672" y="2043684"/>
+          <p:cNvPr id="24" name="Shape 22"/>
+          <p:cNvSpPr/>
+          <p:nvPr/>
+        </p:nvSpPr>
+        <p:spPr>
+          <a:xfrm>
+            <a:off x="5760720" y="2478024"/>
             <a:ext cx="109728" cy="109728"/>
           </a:xfrm>
           <a:prstGeom prst="ellipse">
@@ -11245,13 +11772,13 @@
       </p:sp>
       <p:sp>
         <p:nvSpPr>
-          <p:cNvPr id="8" name="Shape 6"/>
-          <p:cNvSpPr/>
-          <p:nvPr/>
-        </p:nvSpPr>
-        <p:spPr>
-          <a:xfrm>
-            <a:off x="1005840" y="2043684"/>
+          <p:cNvPr id="25" name="Shape 23"/>
+          <p:cNvSpPr/>
+          <p:nvPr/>
+        </p:nvSpPr>
+        <p:spPr>
+          <a:xfrm>
+            <a:off x="5961888" y="2478024"/>
             <a:ext cx="109728" cy="109728"/>
           </a:xfrm>
           <a:prstGeom prst="ellipse">
@@ -11265,13 +11792,13 @@
       </p:sp>
       <p:sp>
         <p:nvSpPr>
-          <p:cNvPr id="9" name="Shape 7"/>
-          <p:cNvSpPr/>
-          <p:nvPr/>
-        </p:nvSpPr>
-        <p:spPr>
-          <a:xfrm>
-            <a:off x="1207008" y="2043684"/>
+          <p:cNvPr id="26" name="Shape 24"/>
+          <p:cNvSpPr/>
+          <p:nvPr/>
+        </p:nvSpPr>
+        <p:spPr>
+          <a:xfrm>
+            <a:off x="6163056" y="2478024"/>
             <a:ext cx="109728" cy="109728"/>
           </a:xfrm>
           <a:prstGeom prst="ellipse">
@@ -11285,30 +11812,30 @@
       </p:sp>
       <p:sp>
         <p:nvSpPr>
-          <p:cNvPr id="10" name="Text 8"/>
-          <p:cNvSpPr/>
-          <p:nvPr/>
-        </p:nvSpPr>
-        <p:spPr>
-          <a:xfrm>
-            <a:off x="1463040" y="1929384"/>
-            <a:ext cx="4572000" cy="347472"/>
-          </a:xfrm>
-          <a:prstGeom prst="rect">
-            <a:avLst/>
-          </a:prstGeom>
-          <a:noFill/>
-          <a:ln/>
-        </p:spPr>
-        <p:txBody>
-          <a:bodyPr wrap="square" lIns="0" tIns="0" rIns="0" bIns="0" rtlCol="0" anchor="ctr"/>
-          <a:lstStyle/>
-          <a:p>
-            <a:pPr algn="l" indent="0" marL="0">
-              <a:buNone/>
-            </a:pPr>
-            <a:r>
-              <a:rPr lang="en-US" sz="1000" dirty="0">
+          <p:cNvPr id="27" name="Text 25"/>
+          <p:cNvSpPr/>
+          <p:nvPr/>
+        </p:nvSpPr>
+        <p:spPr>
+          <a:xfrm>
+            <a:off x="6446520" y="2331720"/>
+            <a:ext cx="4846320" cy="384048"/>
+          </a:xfrm>
+          <a:prstGeom prst="rect">
+            <a:avLst/>
+          </a:prstGeom>
+          <a:noFill/>
+          <a:ln/>
+        </p:spPr>
+        <p:txBody>
+          <a:bodyPr wrap="square" lIns="0" tIns="0" rIns="0" bIns="0" rtlCol="0" anchor="ctr"/>
+          <a:lstStyle/>
+          <a:p>
+            <a:pPr algn="l" indent="0" marL="0">
+              <a:buNone/>
+            </a:pPr>
+            <a:r>
+              <a:rPr lang="en-US" sz="1100" dirty="0">
                 <a:solidFill>
                   <a:srgbClr val="8B949E"/>
                 </a:solidFill>
@@ -11316,744 +11843,39 @@
                 <a:ea typeface="Menlo" pitchFamily="34" charset="-122"/>
                 <a:cs typeface="Menlo" pitchFamily="34" charset="-120"/>
               </a:rPr>
-              <a:t>エージェントが作る構成（例）</a:t>
-            </a:r>
-            <a:endParaRPr lang="en-US" sz="1000" dirty="0"/>
-          </a:p>
-        </p:txBody>
-      </p:sp>
-      <p:sp>
-        <p:nvSpPr>
-          <p:cNvPr id="11" name="Text 9"/>
-          <p:cNvSpPr/>
-          <p:nvPr/>
-        </p:nvSpPr>
-        <p:spPr>
-          <a:xfrm>
-            <a:off x="896112" y="2377440"/>
-            <a:ext cx="5212080" cy="3319272"/>
-          </a:xfrm>
-          <a:prstGeom prst="rect">
-            <a:avLst/>
-          </a:prstGeom>
-          <a:noFill/>
-          <a:ln/>
-        </p:spPr>
-        <p:txBody>
-          <a:bodyPr wrap="square" lIns="0" tIns="0" rIns="0" bIns="0" rtlCol="0" anchor="t"/>
-          <a:lstStyle/>
-          <a:p>
-            <a:pPr algn="l" indent="0" marL="0">
-              <a:lnSpc>
-                <a:spcPct val="125000"/>
-              </a:lnSpc>
-              <a:buNone/>
-            </a:pPr>
-            <a:r>
-              <a:rPr lang="en-US" sz="1400" dirty="0">
-                <a:solidFill>
-                  <a:srgbClr val="8B949E"/>
-                </a:solidFill>
-                <a:latin typeface="Menlo" pitchFamily="34" charset="0"/>
-                <a:ea typeface="Menlo" pitchFamily="34" charset="-122"/>
-                <a:cs typeface="Menlo" pitchFamily="34" charset="-120"/>
-              </a:rPr>
-              <a:t>todo-app/</a:t>
-            </a:r>
-            <a:endParaRPr lang="en-US" sz="1400" dirty="0"/>
-          </a:p>
-          <a:p>
-            <a:pPr algn="l" indent="0" marL="0">
-              <a:lnSpc>
-                <a:spcPct val="125000"/>
-              </a:lnSpc>
-              <a:buNone/>
-            </a:pPr>
-            <a:r>
-              <a:rPr lang="en-US" sz="1400" dirty="0">
-                <a:solidFill>
-                  <a:srgbClr val="C9D1D9"/>
-                </a:solidFill>
-                <a:latin typeface="Menlo" pitchFamily="34" charset="0"/>
-                <a:ea typeface="Menlo" pitchFamily="34" charset="-122"/>
-                <a:cs typeface="Menlo" pitchFamily="34" charset="-120"/>
-              </a:rPr>
-              <a:t>  index.html     画面</a:t>
-            </a:r>
-            <a:endParaRPr lang="en-US" sz="1400" dirty="0"/>
-          </a:p>
-          <a:p>
-            <a:pPr algn="l" indent="0" marL="0">
-              <a:lnSpc>
-                <a:spcPct val="125000"/>
-              </a:lnSpc>
-              <a:buNone/>
-            </a:pPr>
-            <a:r>
-              <a:rPr lang="en-US" sz="1400" dirty="0">
-                <a:solidFill>
-                  <a:srgbClr val="C9D1D9"/>
-                </a:solidFill>
-                <a:latin typeface="Menlo" pitchFamily="34" charset="0"/>
-                <a:ea typeface="Menlo" pitchFamily="34" charset="-122"/>
-                <a:cs typeface="Menlo" pitchFamily="34" charset="-120"/>
-              </a:rPr>
-              <a:t>  styles.css     見た目</a:t>
-            </a:r>
-            <a:endParaRPr lang="en-US" sz="1400" dirty="0"/>
-          </a:p>
-          <a:p>
-            <a:pPr algn="l" indent="0" marL="0">
-              <a:lnSpc>
-                <a:spcPct val="125000"/>
-              </a:lnSpc>
-              <a:buNone/>
-            </a:pPr>
-            <a:r>
-              <a:rPr lang="en-US" sz="1400" dirty="0">
-                <a:solidFill>
-                  <a:srgbClr val="8B949E"/>
-                </a:solidFill>
-                <a:latin typeface="Menlo" pitchFamily="34" charset="0"/>
-                <a:ea typeface="Menlo" pitchFamily="34" charset="-122"/>
-                <a:cs typeface="Menlo" pitchFamily="34" charset="-120"/>
-              </a:rPr>
-              <a:t>  src/</a:t>
-            </a:r>
-            <a:endParaRPr lang="en-US" sz="1400" dirty="0"/>
-          </a:p>
-          <a:p>
-            <a:pPr algn="l" indent="0" marL="0">
-              <a:lnSpc>
-                <a:spcPct val="125000"/>
-              </a:lnSpc>
-              <a:buNone/>
-            </a:pPr>
-            <a:r>
-              <a:rPr lang="en-US" sz="1400" dirty="0">
-                <a:solidFill>
-                  <a:srgbClr val="C9D1D9"/>
-                </a:solidFill>
-                <a:latin typeface="Menlo" pitchFamily="34" charset="0"/>
-                <a:ea typeface="Menlo" pitchFamily="34" charset="-122"/>
-                <a:cs typeface="Menlo" pitchFamily="34" charset="-120"/>
-              </a:rPr>
-              <a:t>    storage.js   保存（localStorage）</a:t>
-            </a:r>
-            <a:endParaRPr lang="en-US" sz="1400" dirty="0"/>
-          </a:p>
-          <a:p>
-            <a:pPr algn="l" indent="0" marL="0">
-              <a:lnSpc>
-                <a:spcPct val="125000"/>
-              </a:lnSpc>
-              <a:buNone/>
-            </a:pPr>
-            <a:r>
-              <a:rPr lang="en-US" sz="1400" dirty="0">
-                <a:solidFill>
-                  <a:srgbClr val="C9D1D9"/>
-                </a:solidFill>
-                <a:latin typeface="Menlo" pitchFamily="34" charset="0"/>
-                <a:ea typeface="Menlo" pitchFamily="34" charset="-122"/>
-                <a:cs typeface="Menlo" pitchFamily="34" charset="-120"/>
-              </a:rPr>
-              <a:t>    todo.js      追加・完了・削除</a:t>
-            </a:r>
-            <a:endParaRPr lang="en-US" sz="1400" dirty="0"/>
-          </a:p>
-          <a:p>
-            <a:pPr algn="l" indent="0" marL="0">
-              <a:lnSpc>
-                <a:spcPct val="125000"/>
-              </a:lnSpc>
-              <a:buNone/>
-            </a:pPr>
-            <a:r>
-              <a:rPr lang="en-US" sz="1400" dirty="0">
-                <a:solidFill>
-                  <a:srgbClr val="C9D1D9"/>
-                </a:solidFill>
-                <a:latin typeface="Menlo" pitchFamily="34" charset="0"/>
-                <a:ea typeface="Menlo" pitchFamily="34" charset="-122"/>
-                <a:cs typeface="Menlo" pitchFamily="34" charset="-120"/>
-              </a:rPr>
-              <a:t>    app.js       画面とロジックの入口</a:t>
-            </a:r>
-            <a:endParaRPr lang="en-US" sz="1400" dirty="0"/>
-          </a:p>
-        </p:txBody>
-      </p:sp>
-      <p:sp>
-        <p:nvSpPr>
-          <p:cNvPr id="12" name="Shape 10"/>
-          <p:cNvSpPr/>
-          <p:nvPr/>
-        </p:nvSpPr>
-        <p:spPr>
-          <a:xfrm>
-            <a:off x="6675120" y="1920240"/>
-            <a:ext cx="4846320" cy="749808"/>
-          </a:xfrm>
-          <a:prstGeom prst="roundRect">
-            <a:avLst>
-              <a:gd name="adj" fmla="val 9756"/>
-            </a:avLst>
-          </a:prstGeom>
-          <a:solidFill>
-            <a:srgbClr val="161B22"/>
-          </a:solidFill>
-          <a:ln w="12700">
-            <a:solidFill>
-              <a:srgbClr val="30363D"/>
-            </a:solidFill>
-            <a:prstDash val="solid"/>
-          </a:ln>
-          <a:effectLst>
-            <a:outerShdw sx="100000" sy="100000" kx="0" ky="0" algn="bl" rotWithShape="0" blurRad="127000" dist="38100" dir="5400000">
-              <a:srgbClr val="000000">
-                <a:alpha val="35000"/>
-              </a:srgbClr>
-            </a:outerShdw>
-          </a:effectLst>
-        </p:spPr>
-      </p:sp>
-      <p:sp>
-        <p:nvSpPr>
-          <p:cNvPr id="13" name="Shape 11"/>
-          <p:cNvSpPr/>
-          <p:nvPr/>
-        </p:nvSpPr>
-        <p:spPr>
-          <a:xfrm>
-            <a:off x="6675120" y="1920240"/>
-            <a:ext cx="82296" cy="749808"/>
-          </a:xfrm>
-          <a:prstGeom prst="rect">
-            <a:avLst/>
-          </a:prstGeom>
-          <a:solidFill>
-            <a:srgbClr val="3FB950"/>
-          </a:solidFill>
-          <a:ln/>
-        </p:spPr>
-      </p:sp>
-      <p:sp>
-        <p:nvSpPr>
-          <p:cNvPr id="14" name="Text 12"/>
-          <p:cNvSpPr/>
-          <p:nvPr/>
-        </p:nvSpPr>
-        <p:spPr>
-          <a:xfrm>
-            <a:off x="7040880" y="2011680"/>
-            <a:ext cx="4206240" cy="365760"/>
-          </a:xfrm>
-          <a:prstGeom prst="rect">
-            <a:avLst/>
-          </a:prstGeom>
-          <a:noFill/>
-          <a:ln/>
-        </p:spPr>
-        <p:txBody>
-          <a:bodyPr wrap="square" lIns="0" tIns="0" rIns="0" bIns="0" rtlCol="0" anchor="ctr"/>
-          <a:lstStyle/>
-          <a:p>
-            <a:pPr algn="l" indent="0" marL="0">
-              <a:buNone/>
-            </a:pPr>
-            <a:r>
-              <a:rPr lang="en-US" sz="1600" b="1" dirty="0">
-                <a:solidFill>
-                  <a:srgbClr val="E6EDF3"/>
-                </a:solidFill>
-                <a:latin typeface="Hiragino Sans" pitchFamily="34" charset="0"/>
-                <a:ea typeface="Hiragino Sans" pitchFamily="34" charset="-122"/>
-                <a:cs typeface="Hiragino Sans" pitchFamily="34" charset="-120"/>
-              </a:rPr>
-              <a:t>タスクを追加</a:t>
-            </a:r>
-            <a:endParaRPr lang="en-US" sz="1600" dirty="0"/>
-          </a:p>
-        </p:txBody>
-      </p:sp>
-      <p:sp>
-        <p:nvSpPr>
-          <p:cNvPr id="15" name="Text 13"/>
-          <p:cNvSpPr/>
-          <p:nvPr/>
-        </p:nvSpPr>
-        <p:spPr>
-          <a:xfrm>
-            <a:off x="7040880" y="2359152"/>
-            <a:ext cx="4206240" cy="292608"/>
-          </a:xfrm>
-          <a:prstGeom prst="rect">
-            <a:avLst/>
-          </a:prstGeom>
-          <a:noFill/>
-          <a:ln/>
-        </p:spPr>
-        <p:txBody>
-          <a:bodyPr wrap="square" lIns="0" tIns="0" rIns="0" bIns="0" rtlCol="0" anchor="ctr"/>
-          <a:lstStyle/>
-          <a:p>
-            <a:pPr algn="l" indent="0" marL="0">
-              <a:buNone/>
-            </a:pPr>
-            <a:r>
-              <a:rPr lang="en-US" sz="1250" dirty="0">
-                <a:solidFill>
-                  <a:srgbClr val="8B949E"/>
-                </a:solidFill>
-                <a:latin typeface="Hiragino Sans" pitchFamily="34" charset="0"/>
-                <a:ea typeface="Hiragino Sans" pitchFamily="34" charset="-122"/>
-                <a:cs typeface="Hiragino Sans" pitchFamily="34" charset="-120"/>
-              </a:rPr>
-              <a:t>入力して「追加」で登録</a:t>
-            </a:r>
-            <a:endParaRPr lang="en-US" sz="1250" dirty="0"/>
-          </a:p>
-        </p:txBody>
-      </p:sp>
-      <p:sp>
-        <p:nvSpPr>
-          <p:cNvPr id="16" name="Shape 14"/>
-          <p:cNvSpPr/>
-          <p:nvPr/>
-        </p:nvSpPr>
-        <p:spPr>
-          <a:xfrm>
-            <a:off x="6675120" y="2798064"/>
-            <a:ext cx="4846320" cy="749808"/>
-          </a:xfrm>
-          <a:prstGeom prst="roundRect">
-            <a:avLst>
-              <a:gd name="adj" fmla="val 9756"/>
-            </a:avLst>
-          </a:prstGeom>
-          <a:solidFill>
-            <a:srgbClr val="161B22"/>
-          </a:solidFill>
-          <a:ln w="12700">
-            <a:solidFill>
-              <a:srgbClr val="30363D"/>
-            </a:solidFill>
-            <a:prstDash val="solid"/>
-          </a:ln>
-          <a:effectLst>
-            <a:outerShdw sx="100000" sy="100000" kx="0" ky="0" algn="bl" rotWithShape="0" blurRad="127000" dist="38100" dir="5400000">
-              <a:srgbClr val="000000">
-                <a:alpha val="35000"/>
-              </a:srgbClr>
-            </a:outerShdw>
-          </a:effectLst>
-        </p:spPr>
-      </p:sp>
-      <p:sp>
-        <p:nvSpPr>
-          <p:cNvPr id="17" name="Shape 15"/>
-          <p:cNvSpPr/>
-          <p:nvPr/>
-        </p:nvSpPr>
-        <p:spPr>
-          <a:xfrm>
-            <a:off x="6675120" y="2798064"/>
-            <a:ext cx="82296" cy="749808"/>
-          </a:xfrm>
-          <a:prstGeom prst="rect">
-            <a:avLst/>
-          </a:prstGeom>
-          <a:solidFill>
-            <a:srgbClr val="58A6FF"/>
-          </a:solidFill>
-          <a:ln/>
-        </p:spPr>
-      </p:sp>
-      <p:sp>
-        <p:nvSpPr>
-          <p:cNvPr id="18" name="Text 16"/>
-          <p:cNvSpPr/>
-          <p:nvPr/>
-        </p:nvSpPr>
-        <p:spPr>
-          <a:xfrm>
-            <a:off x="7040880" y="2889504"/>
-            <a:ext cx="4206240" cy="365760"/>
-          </a:xfrm>
-          <a:prstGeom prst="rect">
-            <a:avLst/>
-          </a:prstGeom>
-          <a:noFill/>
-          <a:ln/>
-        </p:spPr>
-        <p:txBody>
-          <a:bodyPr wrap="square" lIns="0" tIns="0" rIns="0" bIns="0" rtlCol="0" anchor="ctr"/>
-          <a:lstStyle/>
-          <a:p>
-            <a:pPr algn="l" indent="0" marL="0">
-              <a:buNone/>
-            </a:pPr>
-            <a:r>
-              <a:rPr lang="en-US" sz="1600" b="1" dirty="0">
-                <a:solidFill>
-                  <a:srgbClr val="E6EDF3"/>
-                </a:solidFill>
-                <a:latin typeface="Hiragino Sans" pitchFamily="34" charset="0"/>
-                <a:ea typeface="Hiragino Sans" pitchFamily="34" charset="-122"/>
-                <a:cs typeface="Hiragino Sans" pitchFamily="34" charset="-120"/>
-              </a:rPr>
-              <a:t>完了でチェック</a:t>
-            </a:r>
-            <a:endParaRPr lang="en-US" sz="1600" dirty="0"/>
-          </a:p>
-        </p:txBody>
-      </p:sp>
-      <p:sp>
-        <p:nvSpPr>
-          <p:cNvPr id="19" name="Text 17"/>
-          <p:cNvSpPr/>
-          <p:nvPr/>
-        </p:nvSpPr>
-        <p:spPr>
-          <a:xfrm>
-            <a:off x="7040880" y="3236976"/>
-            <a:ext cx="4206240" cy="292608"/>
-          </a:xfrm>
-          <a:prstGeom prst="rect">
-            <a:avLst/>
-          </a:prstGeom>
-          <a:noFill/>
-          <a:ln/>
-        </p:spPr>
-        <p:txBody>
-          <a:bodyPr wrap="square" lIns="0" tIns="0" rIns="0" bIns="0" rtlCol="0" anchor="ctr"/>
-          <a:lstStyle/>
-          <a:p>
-            <a:pPr algn="l" indent="0" marL="0">
-              <a:buNone/>
-            </a:pPr>
-            <a:r>
-              <a:rPr lang="en-US" sz="1250" dirty="0">
-                <a:solidFill>
-                  <a:srgbClr val="8B949E"/>
-                </a:solidFill>
-                <a:latin typeface="Hiragino Sans" pitchFamily="34" charset="0"/>
-                <a:ea typeface="Hiragino Sans" pitchFamily="34" charset="-122"/>
-                <a:cs typeface="Hiragino Sans" pitchFamily="34" charset="-120"/>
-              </a:rPr>
-              <a:t>押すと打ち消し線が付く</a:t>
-            </a:r>
-            <a:endParaRPr lang="en-US" sz="1250" dirty="0"/>
-          </a:p>
-        </p:txBody>
-      </p:sp>
-      <p:sp>
-        <p:nvSpPr>
-          <p:cNvPr id="20" name="Shape 18"/>
-          <p:cNvSpPr/>
-          <p:nvPr/>
-        </p:nvSpPr>
-        <p:spPr>
-          <a:xfrm>
-            <a:off x="6675120" y="3675888"/>
-            <a:ext cx="4846320" cy="749808"/>
-          </a:xfrm>
-          <a:prstGeom prst="roundRect">
-            <a:avLst>
-              <a:gd name="adj" fmla="val 9756"/>
-            </a:avLst>
-          </a:prstGeom>
-          <a:solidFill>
-            <a:srgbClr val="161B22"/>
-          </a:solidFill>
-          <a:ln w="12700">
-            <a:solidFill>
-              <a:srgbClr val="30363D"/>
-            </a:solidFill>
-            <a:prstDash val="solid"/>
-          </a:ln>
-          <a:effectLst>
-            <a:outerShdw sx="100000" sy="100000" kx="0" ky="0" algn="bl" rotWithShape="0" blurRad="127000" dist="38100" dir="5400000">
-              <a:srgbClr val="000000">
-                <a:alpha val="35000"/>
-              </a:srgbClr>
-            </a:outerShdw>
-          </a:effectLst>
-        </p:spPr>
-      </p:sp>
-      <p:sp>
-        <p:nvSpPr>
-          <p:cNvPr id="21" name="Shape 19"/>
-          <p:cNvSpPr/>
-          <p:nvPr/>
-        </p:nvSpPr>
-        <p:spPr>
-          <a:xfrm>
-            <a:off x="6675120" y="3675888"/>
-            <a:ext cx="82296" cy="749808"/>
-          </a:xfrm>
-          <a:prstGeom prst="rect">
-            <a:avLst/>
-          </a:prstGeom>
-          <a:solidFill>
-            <a:srgbClr val="BC8CFF"/>
-          </a:solidFill>
-          <a:ln/>
-        </p:spPr>
-      </p:sp>
-      <p:sp>
-        <p:nvSpPr>
-          <p:cNvPr id="22" name="Text 20"/>
-          <p:cNvSpPr/>
-          <p:nvPr/>
-        </p:nvSpPr>
-        <p:spPr>
-          <a:xfrm>
-            <a:off x="7040880" y="3767328"/>
-            <a:ext cx="4206240" cy="365760"/>
-          </a:xfrm>
-          <a:prstGeom prst="rect">
-            <a:avLst/>
-          </a:prstGeom>
-          <a:noFill/>
-          <a:ln/>
-        </p:spPr>
-        <p:txBody>
-          <a:bodyPr wrap="square" lIns="0" tIns="0" rIns="0" bIns="0" rtlCol="0" anchor="ctr"/>
-          <a:lstStyle/>
-          <a:p>
-            <a:pPr algn="l" indent="0" marL="0">
-              <a:buNone/>
-            </a:pPr>
-            <a:r>
-              <a:rPr lang="en-US" sz="1600" b="1" dirty="0">
-                <a:solidFill>
-                  <a:srgbClr val="E6EDF3"/>
-                </a:solidFill>
-                <a:latin typeface="Hiragino Sans" pitchFamily="34" charset="0"/>
-                <a:ea typeface="Hiragino Sans" pitchFamily="34" charset="-122"/>
-                <a:cs typeface="Hiragino Sans" pitchFamily="34" charset="-120"/>
-              </a:rPr>
-              <a:t>いらないものは削除</a:t>
-            </a:r>
-            <a:endParaRPr lang="en-US" sz="1600" dirty="0"/>
-          </a:p>
-        </p:txBody>
-      </p:sp>
-      <p:sp>
-        <p:nvSpPr>
-          <p:cNvPr id="23" name="Text 21"/>
-          <p:cNvSpPr/>
-          <p:nvPr/>
-        </p:nvSpPr>
-        <p:spPr>
-          <a:xfrm>
-            <a:off x="7040880" y="4114800"/>
-            <a:ext cx="4206240" cy="292608"/>
-          </a:xfrm>
-          <a:prstGeom prst="rect">
-            <a:avLst/>
-          </a:prstGeom>
-          <a:noFill/>
-          <a:ln/>
-        </p:spPr>
-        <p:txBody>
-          <a:bodyPr wrap="square" lIns="0" tIns="0" rIns="0" bIns="0" rtlCol="0" anchor="ctr"/>
-          <a:lstStyle/>
-          <a:p>
-            <a:pPr algn="l" indent="0" marL="0">
-              <a:buNone/>
-            </a:pPr>
-            <a:r>
-              <a:rPr lang="en-US" sz="1250" dirty="0">
-                <a:solidFill>
-                  <a:srgbClr val="8B949E"/>
-                </a:solidFill>
-                <a:latin typeface="Hiragino Sans" pitchFamily="34" charset="0"/>
-                <a:ea typeface="Hiragino Sans" pitchFamily="34" charset="-122"/>
-                <a:cs typeface="Hiragino Sans" pitchFamily="34" charset="-120"/>
-              </a:rPr>
-              <a:t>× ボタンで消える</a:t>
-            </a:r>
-            <a:endParaRPr lang="en-US" sz="1250" dirty="0"/>
-          </a:p>
-        </p:txBody>
-      </p:sp>
-      <p:sp>
-        <p:nvSpPr>
-          <p:cNvPr id="24" name="Shape 22"/>
-          <p:cNvSpPr/>
-          <p:nvPr/>
-        </p:nvSpPr>
-        <p:spPr>
-          <a:xfrm>
-            <a:off x="6675120" y="4553712"/>
-            <a:ext cx="4846320" cy="749808"/>
-          </a:xfrm>
-          <a:prstGeom prst="roundRect">
-            <a:avLst>
-              <a:gd name="adj" fmla="val 9756"/>
-            </a:avLst>
-          </a:prstGeom>
-          <a:solidFill>
-            <a:srgbClr val="161B22"/>
-          </a:solidFill>
-          <a:ln w="12700">
-            <a:solidFill>
-              <a:srgbClr val="30363D"/>
-            </a:solidFill>
-            <a:prstDash val="solid"/>
-          </a:ln>
-          <a:effectLst>
-            <a:outerShdw sx="100000" sy="100000" kx="0" ky="0" algn="bl" rotWithShape="0" blurRad="127000" dist="38100" dir="5400000">
-              <a:srgbClr val="000000">
-                <a:alpha val="35000"/>
-              </a:srgbClr>
-            </a:outerShdw>
-          </a:effectLst>
-        </p:spPr>
-      </p:sp>
-      <p:sp>
-        <p:nvSpPr>
-          <p:cNvPr id="25" name="Shape 23"/>
-          <p:cNvSpPr/>
-          <p:nvPr/>
-        </p:nvSpPr>
-        <p:spPr>
-          <a:xfrm>
-            <a:off x="6675120" y="4553712"/>
-            <a:ext cx="82296" cy="749808"/>
-          </a:xfrm>
-          <a:prstGeom prst="rect">
-            <a:avLst/>
-          </a:prstGeom>
-          <a:solidFill>
-            <a:srgbClr val="F0883E"/>
-          </a:solidFill>
-          <a:ln/>
-        </p:spPr>
-      </p:sp>
-      <p:sp>
-        <p:nvSpPr>
-          <p:cNvPr id="26" name="Text 24"/>
-          <p:cNvSpPr/>
-          <p:nvPr/>
-        </p:nvSpPr>
-        <p:spPr>
-          <a:xfrm>
-            <a:off x="7040880" y="4645152"/>
-            <a:ext cx="4206240" cy="365760"/>
-          </a:xfrm>
-          <a:prstGeom prst="rect">
-            <a:avLst/>
-          </a:prstGeom>
-          <a:noFill/>
-          <a:ln/>
-        </p:spPr>
-        <p:txBody>
-          <a:bodyPr wrap="square" lIns="0" tIns="0" rIns="0" bIns="0" rtlCol="0" anchor="ctr"/>
-          <a:lstStyle/>
-          <a:p>
-            <a:pPr algn="l" indent="0" marL="0">
-              <a:buNone/>
-            </a:pPr>
-            <a:r>
-              <a:rPr lang="en-US" sz="1600" b="1" dirty="0">
-                <a:solidFill>
-                  <a:srgbClr val="E6EDF3"/>
-                </a:solidFill>
-                <a:latin typeface="Hiragino Sans" pitchFamily="34" charset="0"/>
-                <a:ea typeface="Hiragino Sans" pitchFamily="34" charset="-122"/>
-                <a:cs typeface="Hiragino Sans" pitchFamily="34" charset="-120"/>
-              </a:rPr>
-              <a:t>閉じても残る</a:t>
-            </a:r>
-            <a:endParaRPr lang="en-US" sz="1600" dirty="0"/>
-          </a:p>
-        </p:txBody>
-      </p:sp>
-      <p:sp>
-        <p:nvSpPr>
-          <p:cNvPr id="27" name="Text 25"/>
-          <p:cNvSpPr/>
-          <p:nvPr/>
-        </p:nvSpPr>
-        <p:spPr>
-          <a:xfrm>
-            <a:off x="7040880" y="4992624"/>
-            <a:ext cx="4206240" cy="292608"/>
-          </a:xfrm>
-          <a:prstGeom prst="rect">
-            <a:avLst/>
-          </a:prstGeom>
-          <a:noFill/>
-          <a:ln/>
-        </p:spPr>
-        <p:txBody>
-          <a:bodyPr wrap="square" lIns="0" tIns="0" rIns="0" bIns="0" rtlCol="0" anchor="ctr"/>
-          <a:lstStyle/>
-          <a:p>
-            <a:pPr algn="l" indent="0" marL="0">
-              <a:buNone/>
-            </a:pPr>
-            <a:r>
-              <a:rPr lang="en-US" sz="1250" dirty="0">
-                <a:solidFill>
-                  <a:srgbClr val="8B949E"/>
-                </a:solidFill>
-                <a:latin typeface="Hiragino Sans" pitchFamily="34" charset="0"/>
-                <a:ea typeface="Hiragino Sans" pitchFamily="34" charset="-122"/>
-                <a:cs typeface="Hiragino Sans" pitchFamily="34" charset="-120"/>
-              </a:rPr>
-              <a:t>localStorage に保存</a:t>
-            </a:r>
-            <a:endParaRPr lang="en-US" sz="1250" dirty="0"/>
-          </a:p>
-        </p:txBody>
-      </p:sp>
-      <p:sp>
-        <p:nvSpPr>
-          <p:cNvPr id="28" name="Text 26"/>
-          <p:cNvSpPr/>
-          <p:nvPr/>
-        </p:nvSpPr>
-        <p:spPr>
-          <a:xfrm>
-            <a:off x="6675120" y="5532120"/>
-            <a:ext cx="4846320" cy="274320"/>
-          </a:xfrm>
-          <a:prstGeom prst="rect">
-            <a:avLst/>
-          </a:prstGeom>
-          <a:noFill/>
-          <a:ln/>
-        </p:spPr>
-        <p:txBody>
-          <a:bodyPr wrap="square" lIns="0" tIns="0" rIns="0" bIns="0" rtlCol="0" anchor="ctr"/>
-          <a:lstStyle/>
-          <a:p>
-            <a:pPr algn="l" indent="0" marL="0">
-              <a:buNone/>
-            </a:pPr>
-            <a:r>
-              <a:rPr lang="en-US" sz="1250" dirty="0">
-                <a:solidFill>
-                  <a:srgbClr val="3FB950"/>
-                </a:solidFill>
-                <a:latin typeface="Hiragino Sans" pitchFamily="34" charset="0"/>
-                <a:ea typeface="Hiragino Sans" pitchFamily="34" charset="-122"/>
-                <a:cs typeface="Hiragino Sans" pitchFamily="34" charset="-120"/>
-              </a:rPr>
-              <a:t>どう分けるかも、まとめてエージェントが考えてくれます。</a:t>
-            </a:r>
-            <a:endParaRPr lang="en-US" sz="1250" dirty="0"/>
-          </a:p>
-        </p:txBody>
-      </p:sp>
-      <p:sp>
-        <p:nvSpPr>
-          <p:cNvPr id="29" name="Text 27"/>
+              <a:t>opencode で生成した実物</a:t>
+            </a:r>
+            <a:endParaRPr lang="en-US" sz="1100" dirty="0"/>
+          </a:p>
+        </p:txBody>
+      </p:sp>
+      <p:pic>
+        <p:nvPicPr>
+          <p:cNvPr id="28" name="Image 0" descr="/Users/ojii3/src/github.com/OJII3/opencode_openrouter_free_example/slides/assets/todo-hands-on-screenshot.png">    </p:cNvPr>
+          <p:cNvPicPr>
+            <a:picLocks noChangeAspect="1"/>
+          </p:cNvPicPr>
+          <p:nvPr/>
+        </p:nvPicPr>
+        <p:blipFill>
+          <a:blip r:embed="rId1"/>
+          <a:stretch>
+            <a:fillRect/>
+          </a:stretch>
+        </p:blipFill>
+        <p:spPr>
+          <a:xfrm>
+            <a:off x="5779008" y="2889504"/>
+            <a:ext cx="5577840" cy="2697480"/>
+          </a:xfrm>
+          <a:prstGeom prst="rect">
+            <a:avLst/>
+          </a:prstGeom>
+        </p:spPr>
+      </p:pic>
+      <p:sp>
+        <p:nvSpPr>
+          <p:cNvPr id="29" name="Text 26"/>
           <p:cNvSpPr/>
           <p:nvPr/>
         </p:nvSpPr>
@@ -12106,7 +11928,7 @@
       </p:sp>
       <p:sp>
         <p:nvSpPr>
-          <p:cNvPr id="30" name="Text 28"/>
+          <p:cNvPr id="30" name="Text 27"/>
           <p:cNvSpPr/>
           <p:nvPr/>
         </p:nvSpPr>
@@ -12286,7 +12108,7 @@
                 <a:ea typeface="Hiragino Sans" pitchFamily="34" charset="-122"/>
                 <a:cs typeface="Hiragino Sans" pitchFamily="34" charset="-120"/>
               </a:rPr>
-              <a:t>プロンプトはシンプルでいい</a:t>
+              <a:t>このプロンプトを貼る</a:t>
             </a:r>
             <a:endParaRPr lang="en-US" sz="2900" dirty="0"/>
           </a:p>
@@ -12300,8 +12122,8 @@
         </p:nvSpPr>
         <p:spPr>
           <a:xfrm>
-            <a:off x="640080" y="1783080"/>
-            <a:ext cx="10908792" cy="457200"/>
+            <a:off x="640080" y="1673352"/>
+            <a:ext cx="10908792" cy="411480"/>
           </a:xfrm>
           <a:prstGeom prst="rect">
             <a:avLst/>
@@ -12325,7 +12147,7 @@
                 <a:ea typeface="Hiragino Sans" pitchFamily="34" charset="-122"/>
                 <a:cs typeface="Hiragino Sans" pitchFamily="34" charset="-120"/>
               </a:rPr>
-              <a:t>「作りたいもの」と「こうなってほしい」を伝えるだけ。作り方はエージェントが考えます。</a:t>
+              <a:t>完成条件まで書いておくと、無料モデルでも結果が安定します。</a:t>
             </a:r>
             <a:endParaRPr lang="en-US" sz="1600" dirty="0"/>
           </a:p>
@@ -12339,12 +12161,12 @@
         </p:nvSpPr>
         <p:spPr>
           <a:xfrm>
-            <a:off x="640080" y="2468880"/>
-            <a:ext cx="10908792" cy="2514600"/>
+            <a:off x="640080" y="2057400"/>
+            <a:ext cx="10908792" cy="3886200"/>
           </a:xfrm>
           <a:prstGeom prst="roundRect">
             <a:avLst>
-              <a:gd name="adj" fmla="val 2182"/>
+              <a:gd name="adj" fmla="val 1412"/>
             </a:avLst>
           </a:prstGeom>
           <a:solidFill>
@@ -12373,7 +12195,7 @@
         </p:nvSpPr>
         <p:spPr>
           <a:xfrm>
-            <a:off x="649224" y="2478024"/>
+            <a:off x="649224" y="2066544"/>
             <a:ext cx="10890504" cy="347472"/>
           </a:xfrm>
           <a:prstGeom prst="rect">
@@ -12393,7 +12215,7 @@
         </p:nvSpPr>
         <p:spPr>
           <a:xfrm>
-            <a:off x="804672" y="2592324"/>
+            <a:off x="804672" y="2180844"/>
             <a:ext cx="109728" cy="109728"/>
           </a:xfrm>
           <a:prstGeom prst="ellipse">
@@ -12413,7 +12235,7 @@
         </p:nvSpPr>
         <p:spPr>
           <a:xfrm>
-            <a:off x="1005840" y="2592324"/>
+            <a:off x="1005840" y="2180844"/>
             <a:ext cx="109728" cy="109728"/>
           </a:xfrm>
           <a:prstGeom prst="ellipse">
@@ -12433,7 +12255,7 @@
         </p:nvSpPr>
         <p:spPr>
           <a:xfrm>
-            <a:off x="1207008" y="2592324"/>
+            <a:off x="1207008" y="2180844"/>
             <a:ext cx="109728" cy="109728"/>
           </a:xfrm>
           <a:prstGeom prst="ellipse">
@@ -12453,7 +12275,7 @@
         </p:nvSpPr>
         <p:spPr>
           <a:xfrm>
-            <a:off x="1463040" y="2478024"/>
+            <a:off x="1463040" y="2066544"/>
             <a:ext cx="9811512" cy="347472"/>
           </a:xfrm>
           <a:prstGeom prst="rect">
@@ -12492,8 +12314,8 @@
         </p:nvSpPr>
         <p:spPr>
           <a:xfrm>
-            <a:off x="896112" y="2926080"/>
-            <a:ext cx="10451592" cy="1947672"/>
+            <a:off x="896112" y="2514600"/>
+            <a:ext cx="10451592" cy="3319272"/>
           </a:xfrm>
           <a:prstGeom prst="rect">
             <a:avLst/>
@@ -12512,7 +12334,7 @@
               <a:buNone/>
             </a:pPr>
             <a:r>
-              <a:rPr lang="en-US" sz="1500" dirty="0">
+              <a:rPr lang="en-US" sz="1030" dirty="0">
                 <a:solidFill>
                   <a:srgbClr val="E6EDF3"/>
                 </a:solidFill>
@@ -12520,9 +12342,9 @@
                 <a:ea typeface="Menlo" pitchFamily="34" charset="-122"/>
                 <a:cs typeface="Menlo" pitchFamily="34" charset="-120"/>
               </a:rPr>
-              <a:t>ToDoアプリを作って。</a:t>
-            </a:r>
-            <a:endParaRPr lang="en-US" sz="1500" dirty="0"/>
+              <a:t>ミニToDoアプリを index.html 1ファイルで作ってください。</a:t>
+            </a:r>
+            <a:endParaRPr lang="en-US" sz="1030" dirty="0"/>
           </a:p>
           <a:p>
             <a:pPr algn="l" indent="0" marL="0">
@@ -12532,7 +12354,7 @@
               <a:buNone/>
             </a:pPr>
             <a:r>
-              <a:rPr lang="en-US" sz="1500" dirty="0">
+              <a:rPr lang="en-US" sz="1030" dirty="0">
                 <a:solidFill>
                   <a:srgbClr val="C9D1D9"/>
                 </a:solidFill>
@@ -12540,9 +12362,9 @@
                 <a:ea typeface="Menlo" pitchFamily="34" charset="-122"/>
                 <a:cs typeface="Menlo" pitchFamily="34" charset="-120"/>
               </a:rPr>
-              <a:t>・タスクの追加・完了チェック・削除ができる</a:t>
-            </a:r>
-            <a:endParaRPr lang="en-US" sz="1500" dirty="0"/>
+              <a:t>- タスクの追加、完了切り替え、削除ができる</a:t>
+            </a:r>
+            <a:endParaRPr lang="en-US" sz="1030" dirty="0"/>
           </a:p>
           <a:p>
             <a:pPr algn="l" indent="0" marL="0">
@@ -12552,7 +12374,7 @@
               <a:buNone/>
             </a:pPr>
             <a:r>
-              <a:rPr lang="en-US" sz="1500" dirty="0">
+              <a:rPr lang="en-US" sz="1030" dirty="0">
                 <a:solidFill>
                   <a:srgbClr val="C9D1D9"/>
                 </a:solidFill>
@@ -12560,9 +12382,9 @@
                 <a:ea typeface="Menlo" pitchFamily="34" charset="-122"/>
                 <a:cs typeface="Menlo" pitchFamily="34" charset="-120"/>
               </a:rPr>
-              <a:t>・閉じても内容が残るようにする</a:t>
-            </a:r>
-            <a:endParaRPr lang="en-US" sz="1500" dirty="0"/>
+              <a:t>- 残り件数と完了件数を表示する</a:t>
+            </a:r>
+            <a:endParaRPr lang="en-US" sz="1030" dirty="0"/>
           </a:p>
           <a:p>
             <a:pPr algn="l" indent="0" marL="0">
@@ -12572,7 +12394,7 @@
               <a:buNone/>
             </a:pPr>
             <a:r>
-              <a:rPr lang="en-US" sz="1500" dirty="0">
+              <a:rPr lang="en-US" sz="1030" dirty="0">
                 <a:solidFill>
                   <a:srgbClr val="C9D1D9"/>
                 </a:solidFill>
@@ -12580,9 +12402,9 @@
                 <a:ea typeface="Menlo" pitchFamily="34" charset="-122"/>
                 <a:cs typeface="Menlo" pitchFamily="34" charset="-120"/>
               </a:rPr>
-              <a:t>・コードは役割ごとに複数のファイルに分ける</a:t>
-            </a:r>
-            <a:endParaRPr lang="en-US" sz="1500" dirty="0"/>
+              <a:t>- localStorage に保存し、再読み込み後も残る</a:t>
+            </a:r>
+            <a:endParaRPr lang="en-US" sz="1030" dirty="0"/>
           </a:p>
           <a:p>
             <a:pPr algn="l" indent="0" marL="0">
@@ -12592,7 +12414,7 @@
               <a:buNone/>
             </a:pPr>
             <a:r>
-              <a:rPr lang="en-US" sz="1500" dirty="0">
+              <a:rPr lang="en-US" sz="1030" dirty="0">
                 <a:solidFill>
                   <a:srgbClr val="C9D1D9"/>
                 </a:solidFill>
@@ -12600,9 +12422,209 @@
                 <a:ea typeface="Menlo" pitchFamily="34" charset="-122"/>
                 <a:cs typeface="Menlo" pitchFamily="34" charset="-120"/>
               </a:rPr>
-              <a:t>・見た目もシンプルに整える</a:t>
-            </a:r>
-            <a:endParaRPr lang="en-US" sz="1500" dirty="0"/>
+              <a:t>- 初回表示時はサンプルタスクを3件入れる</a:t>
+            </a:r>
+            <a:endParaRPr lang="en-US" sz="1030" dirty="0"/>
+          </a:p>
+          <a:p>
+            <a:pPr algn="l" indent="0" marL="0">
+              <a:lnSpc>
+                <a:spcPct val="125000"/>
+              </a:lnSpc>
+              <a:buNone/>
+            </a:pPr>
+            <a:r>
+              <a:rPr lang="en-US" sz="1030" dirty="0">
+                <a:solidFill>
+                  <a:srgbClr val="C9D1D9"/>
+                </a:solidFill>
+                <a:latin typeface="Menlo" pitchFamily="34" charset="0"/>
+                <a:ea typeface="Menlo" pitchFamily="34" charset="-122"/>
+                <a:cs typeface="Menlo" pitchFamily="34" charset="-120"/>
+              </a:rPr>
+              <a:t>- スマホでもPCでも見やすいカード風の見た目</a:t>
+            </a:r>
+            <a:endParaRPr lang="en-US" sz="1030" dirty="0"/>
+          </a:p>
+          <a:p>
+            <a:pPr algn="l" indent="0" marL="0">
+              <a:lnSpc>
+                <a:spcPct val="125000"/>
+              </a:lnSpc>
+              <a:buNone/>
+            </a:pPr>
+            <a:r>
+              <a:rPr lang="en-US" sz="1030" dirty="0">
+                <a:solidFill>
+                  <a:srgbClr val="C9D1D9"/>
+                </a:solidFill>
+                <a:latin typeface="Menlo" pitchFamily="34" charset="0"/>
+                <a:ea typeface="Menlo" pitchFamily="34" charset="-122"/>
+                <a:cs typeface="Menlo" pitchFamily="34" charset="-120"/>
+              </a:rPr>
+              <a:t> </a:t>
+            </a:r>
+            <a:endParaRPr lang="en-US" sz="1030" dirty="0"/>
+          </a:p>
+          <a:p>
+            <a:pPr algn="l" indent="0" marL="0">
+              <a:lnSpc>
+                <a:spcPct val="125000"/>
+              </a:lnSpc>
+              <a:buNone/>
+            </a:pPr>
+            <a:r>
+              <a:rPr lang="en-US" sz="1030" dirty="0">
+                <a:solidFill>
+                  <a:srgbClr val="F0883E"/>
+                </a:solidFill>
+                <a:latin typeface="Menlo" pitchFamily="34" charset="0"/>
+                <a:ea typeface="Menlo" pitchFamily="34" charset="-122"/>
+                <a:cs typeface="Menlo" pitchFamily="34" charset="-120"/>
+              </a:rPr>
+              <a:t>実装条件:</a:t>
+            </a:r>
+            <a:endParaRPr lang="en-US" sz="1030" dirty="0"/>
+          </a:p>
+          <a:p>
+            <a:pPr algn="l" indent="0" marL="0">
+              <a:lnSpc>
+                <a:spcPct val="125000"/>
+              </a:lnSpc>
+              <a:buNone/>
+            </a:pPr>
+            <a:r>
+              <a:rPr lang="en-US" sz="1030" dirty="0">
+                <a:solidFill>
+                  <a:srgbClr val="C9D1D9"/>
+                </a:solidFill>
+                <a:latin typeface="Menlo" pitchFamily="34" charset="0"/>
+                <a:ea typeface="Menlo" pitchFamily="34" charset="-122"/>
+                <a:cs typeface="Menlo" pitchFamily="34" charset="-120"/>
+              </a:rPr>
+              <a:t>- 外部ライブラリは使わない</a:t>
+            </a:r>
+            <a:endParaRPr lang="en-US" sz="1030" dirty="0"/>
+          </a:p>
+          <a:p>
+            <a:pPr algn="l" indent="0" marL="0">
+              <a:lnSpc>
+                <a:spcPct val="125000"/>
+              </a:lnSpc>
+              <a:buNone/>
+            </a:pPr>
+            <a:r>
+              <a:rPr lang="en-US" sz="1030" dirty="0">
+                <a:solidFill>
+                  <a:srgbClr val="C9D1D9"/>
+                </a:solidFill>
+                <a:latin typeface="Menlo" pitchFamily="34" charset="0"/>
+                <a:ea typeface="Menlo" pitchFamily="34" charset="-122"/>
+                <a:cs typeface="Menlo" pitchFamily="34" charset="-120"/>
+              </a:rPr>
+              <a:t>- CSS は head 内の style にまとめる</a:t>
+            </a:r>
+            <a:endParaRPr lang="en-US" sz="1030" dirty="0"/>
+          </a:p>
+          <a:p>
+            <a:pPr algn="l" indent="0" marL="0">
+              <a:lnSpc>
+                <a:spcPct val="125000"/>
+              </a:lnSpc>
+              <a:buNone/>
+            </a:pPr>
+            <a:r>
+              <a:rPr lang="en-US" sz="1030" dirty="0">
+                <a:solidFill>
+                  <a:srgbClr val="C9D1D9"/>
+                </a:solidFill>
+                <a:latin typeface="Menlo" pitchFamily="34" charset="0"/>
+                <a:ea typeface="Menlo" pitchFamily="34" charset="-122"/>
+                <a:cs typeface="Menlo" pitchFamily="34" charset="-120"/>
+              </a:rPr>
+              <a:t>- JS は body 末尾の script にまとめる</a:t>
+            </a:r>
+            <a:endParaRPr lang="en-US" sz="1030" dirty="0"/>
+          </a:p>
+          <a:p>
+            <a:pPr algn="l" indent="0" marL="0">
+              <a:lnSpc>
+                <a:spcPct val="125000"/>
+              </a:lnSpc>
+              <a:buNone/>
+            </a:pPr>
+            <a:r>
+              <a:rPr lang="en-US" sz="1030" dirty="0">
+                <a:solidFill>
+                  <a:srgbClr val="C9D1D9"/>
+                </a:solidFill>
+                <a:latin typeface="Menlo" pitchFamily="34" charset="0"/>
+                <a:ea typeface="Menlo" pitchFamily="34" charset="-122"/>
+                <a:cs typeface="Menlo" pitchFamily="34" charset="-120"/>
+              </a:rPr>
+              <a:t>- HTML のタグが壊れていないか確認する</a:t>
+            </a:r>
+            <a:endParaRPr lang="en-US" sz="1030" dirty="0"/>
+          </a:p>
+          <a:p>
+            <a:pPr algn="l" indent="0" marL="0">
+              <a:lnSpc>
+                <a:spcPct val="125000"/>
+              </a:lnSpc>
+              <a:buNone/>
+            </a:pPr>
+            <a:r>
+              <a:rPr lang="en-US" sz="1030" dirty="0">
+                <a:solidFill>
+                  <a:srgbClr val="C9D1D9"/>
+                </a:solidFill>
+                <a:latin typeface="Menlo" pitchFamily="34" charset="0"/>
+                <a:ea typeface="Menlo" pitchFamily="34" charset="-122"/>
+                <a:cs typeface="Menlo" pitchFamily="34" charset="-120"/>
+              </a:rPr>
+              <a:t> </a:t>
+            </a:r>
+            <a:endParaRPr lang="en-US" sz="1030" dirty="0"/>
+          </a:p>
+          <a:p>
+            <a:pPr algn="l" indent="0" marL="0">
+              <a:lnSpc>
+                <a:spcPct val="125000"/>
+              </a:lnSpc>
+              <a:buNone/>
+            </a:pPr>
+            <a:r>
+              <a:rPr lang="en-US" sz="1030" dirty="0">
+                <a:solidFill>
+                  <a:srgbClr val="3FB950"/>
+                </a:solidFill>
+                <a:latin typeface="Menlo" pitchFamily="34" charset="0"/>
+                <a:ea typeface="Menlo" pitchFamily="34" charset="-122"/>
+                <a:cs typeface="Menlo" pitchFamily="34" charset="-120"/>
+              </a:rPr>
+              <a:t>最後に確認手順を1行で教えてください:</a:t>
+            </a:r>
+            <a:endParaRPr lang="en-US" sz="1030" dirty="0"/>
+          </a:p>
+          <a:p>
+            <a:pPr algn="l" indent="0" marL="0">
+              <a:lnSpc>
+                <a:spcPct val="125000"/>
+              </a:lnSpc>
+              <a:buNone/>
+            </a:pPr>
+            <a:r>
+              <a:rPr lang="en-US" sz="1030" dirty="0">
+                <a:solidFill>
+                  <a:srgbClr val="3FB950"/>
+                </a:solidFill>
+                <a:latin typeface="Menlo" pitchFamily="34" charset="0"/>
+                <a:ea typeface="Menlo" pitchFamily="34" charset="-122"/>
+                <a:cs typeface="Menlo" pitchFamily="34" charset="-120"/>
+              </a:rPr>
+              <a:t>python3 -m http.server 8000</a:t>
+            </a:r>
+            <a:endParaRPr lang="en-US" sz="1030" dirty="0"/>
           </a:p>
         </p:txBody>
       </p:sp>
@@ -12614,12 +12636,12 @@
         </p:nvSpPr>
         <p:spPr>
           <a:xfrm>
-            <a:off x="640080" y="5166360"/>
-            <a:ext cx="10908792" cy="868680"/>
+            <a:off x="640080" y="5870448"/>
+            <a:ext cx="10908792" cy="411480"/>
           </a:xfrm>
           <a:prstGeom prst="roundRect">
             <a:avLst>
-              <a:gd name="adj" fmla="val 8421"/>
+              <a:gd name="adj" fmla="val 17778"/>
             </a:avLst>
           </a:prstGeom>
           <a:solidFill>
@@ -12648,8 +12670,8 @@
         </p:nvSpPr>
         <p:spPr>
           <a:xfrm>
-            <a:off x="640080" y="5166360"/>
-            <a:ext cx="82296" cy="868680"/>
+            <a:off x="640080" y="5870448"/>
+            <a:ext cx="82296" cy="411480"/>
           </a:xfrm>
           <a:prstGeom prst="rect">
             <a:avLst/>
@@ -12668,24 +12690,24 @@
         </p:nvSpPr>
         <p:spPr>
           <a:xfrm>
-            <a:off x="1005840" y="5166360"/>
-            <a:ext cx="10268712" cy="868680"/>
-          </a:xfrm>
-          <a:prstGeom prst="rect">
-            <a:avLst/>
-          </a:prstGeom>
-          <a:noFill/>
-          <a:ln/>
-        </p:spPr>
-        <p:txBody>
-          <a:bodyPr wrap="square" lIns="0" tIns="0" rIns="0" bIns="0" rtlCol="0" anchor="ctr"/>
-          <a:lstStyle/>
-          <a:p>
-            <a:pPr algn="l" indent="0" marL="0">
-              <a:buNone/>
-            </a:pPr>
-            <a:r>
-              <a:rPr lang="en-US" sz="1500" b="1" dirty="0">
+            <a:off x="1005840" y="5870448"/>
+            <a:ext cx="10268712" cy="411480"/>
+          </a:xfrm>
+          <a:prstGeom prst="rect">
+            <a:avLst/>
+          </a:prstGeom>
+          <a:noFill/>
+          <a:ln/>
+        </p:spPr>
+        <p:txBody>
+          <a:bodyPr wrap="square" lIns="0" tIns="0" rIns="0" bIns="0" rtlCol="0" anchor="ctr"/>
+          <a:lstStyle/>
+          <a:p>
+            <a:pPr algn="l" indent="0" marL="0">
+              <a:buNone/>
+            </a:pPr>
+            <a:r>
+              <a:rPr lang="en-US" sz="1300" b="1" dirty="0">
                 <a:solidFill>
                   <a:srgbClr val="E6EDF3"/>
                 </a:solidFill>
@@ -12693,13 +12715,13 @@
                 <a:ea typeface="Hiragino Sans" pitchFamily="34" charset="-122"/>
                 <a:cs typeface="Hiragino Sans" pitchFamily="34" charset="-120"/>
               </a:rPr>
-              <a:t>ファイル名や分け方までは指定しなくてOK。</a:t>
-            </a:r>
-            <a:pPr algn="l" indent="0" marL="0">
-              <a:buNone/>
-            </a:pPr>
-            <a:r>
-              <a:rPr lang="en-US" sz="1500" dirty="0">
+              <a:t>ポイント：</a:t>
+            </a:r>
+            <a:pPr algn="l" indent="0" marL="0">
+              <a:buNone/>
+            </a:pPr>
+            <a:r>
+              <a:rPr lang="en-US" sz="1300" dirty="0">
                 <a:solidFill>
                   <a:srgbClr val="C9D1D9"/>
                 </a:solidFill>
@@ -12707,9 +12729,9 @@
                 <a:ea typeface="Hiragino Sans" pitchFamily="34" charset="-122"/>
                 <a:cs typeface="Hiragino Sans" pitchFamily="34" charset="-120"/>
               </a:rPr>
-              <a:t> どう作るかはエージェントが判断します。</a:t>
-            </a:r>
-            <a:endParaRPr lang="en-US" sz="1500" dirty="0"/>
+              <a:t> 何を作るかだけでなく、成功条件と確認方法まで一緒に渡す。</a:t>
+            </a:r>
+            <a:endParaRPr lang="en-US" sz="1300" dirty="0"/>
           </a:p>
         </p:txBody>
       </p:sp>
@@ -13726,16 +13748,16 @@
         <p:spPr>
           <a:xfrm>
             <a:off x="640080" y="1645920"/>
-            <a:ext cx="5486400" cy="822960"/>
-          </a:xfrm>
-          <a:prstGeom prst="rect">
-            <a:avLst/>
-          </a:prstGeom>
-          <a:noFill/>
-          <a:ln/>
-        </p:spPr>
-        <p:txBody>
-          <a:bodyPr wrap="square" lIns="0" tIns="0" rIns="0" bIns="0" rtlCol="0" anchor="t"/>
+            <a:ext cx="5486400" cy="502920"/>
+          </a:xfrm>
+          <a:prstGeom prst="rect">
+            <a:avLst/>
+          </a:prstGeom>
+          <a:noFill/>
+          <a:ln/>
+        </p:spPr>
+        <p:txBody>
+          <a:bodyPr wrap="square" lIns="0" tIns="0" rIns="0" bIns="0" rtlCol="0" anchor="ctr"/>
           <a:lstStyle/>
           <a:p>
             <a:pPr algn="l" indent="0" marL="0">
@@ -13753,27 +13775,7 @@
                 <a:ea typeface="Hiragino Sans" pitchFamily="34" charset="-122"/>
                 <a:cs typeface="Hiragino Sans" pitchFamily="34" charset="-120"/>
               </a:rPr>
-              <a:t>分割したコードは “ローカルサーバー” で開きます。</a:t>
-            </a:r>
-            <a:endParaRPr lang="en-US" sz="1500" dirty="0"/>
-          </a:p>
-          <a:p>
-            <a:pPr algn="l" indent="0" marL="0">
-              <a:lnSpc>
-                <a:spcPct val="130000"/>
-              </a:lnSpc>
-              <a:buNone/>
-            </a:pPr>
-            <a:r>
-              <a:rPr lang="en-US" sz="1500" dirty="0">
-                <a:solidFill>
-                  <a:srgbClr val="C9D1D9"/>
-                </a:solidFill>
-                <a:latin typeface="Hiragino Sans" pitchFamily="34" charset="0"/>
-                <a:ea typeface="Hiragino Sans" pitchFamily="34" charset="-122"/>
-                <a:cs typeface="Hiragino Sans" pitchFamily="34" charset="-120"/>
-              </a:rPr>
-              <a:t>（ダブルクリックでは動きません）</a:t>
+              <a:t>生成された index.html をブラウザで開いて、実際に操作します。</a:t>
             </a:r>
             <a:endParaRPr lang="en-US" sz="1500" dirty="0"/>
           </a:p>
@@ -14164,7 +14166,7 @@
                 <a:ea typeface="Hiragino Sans" pitchFamily="34" charset="-122"/>
                 <a:cs typeface="Hiragino Sans" pitchFamily="34" charset="-120"/>
               </a:rPr>
-              <a:t>「このフォルダをローカルサーバーで開いて」と言えば、起動まで任せられます。</a:t>
+              <a:t>「このフォルダをブラウザで開いて確認して」と言えば、確認まで任せられます。</a:t>
             </a:r>
             <a:endParaRPr lang="en-US" sz="1350" dirty="0"/>
           </a:p>
@@ -16027,7 +16029,7 @@
                 <a:ea typeface="Menlo" pitchFamily="34" charset="-122"/>
                 <a:cs typeface="Menlo" pitchFamily="34" charset="-120"/>
               </a:rPr>
-              <a:t>- アプリは複数ファイルに分けて作る</a:t>
+              <a:t>- ハンズオンは index.html 1枚で作る</a:t>
             </a:r>
             <a:endParaRPr lang="en-US" sz="1300" dirty="0"/>
           </a:p>
@@ -17495,7 +17497,7 @@
                 <a:ea typeface="Hiragino Sans" pitchFamily="34" charset="-122"/>
                 <a:cs typeface="Hiragino Sans" pitchFamily="34" charset="-120"/>
               </a:rPr>
-              <a:t>複数ファイルの ToDo アプリを作らせた</a:t>
+              <a:t>ToDo ミニアプリを作らせて確認した</a:t>
             </a:r>
             <a:endParaRPr lang="en-US" sz="1800" dirty="0"/>
           </a:p>

</xml_diff>

<commit_message>
Refine mini app hands-on prompt (#3)
* Refine mini app hands-on prompt

* fix: プロンプトスライドのテキストはみ出しを修正

- codeBlock を y=2.16→1.73 に上移動しサブタイトル行を削除
- 17行→15行に削減（冗長な2行を除去）、fontSize 9.5→10 に拡大
- カードを codeBlock 下端(6.21)より下の y=6.3 に正しく配置

Co-Authored-By: Claude Sonnet 4.6 <noreply@anthropic.com>

---------

Co-authored-by: Claude Sonnet 4.6 <noreply@anthropic.com>
</commit_message>
<xml_diff>
--- a/slides/seminar.pptx
+++ b/slides/seminar.pptx
@@ -10742,7 +10742,7 @@
                 <a:ea typeface="Menlo" pitchFamily="34" charset="-122"/>
                 <a:cs typeface="Menlo" pitchFamily="34" charset="-120"/>
               </a:rPr>
-              <a:t>&gt; ToDoアプリを作って</a:t>
+              <a:t>&gt; ミニToDoアプリを作って</a:t>
             </a:r>
             <a:endParaRPr lang="en-US" sz="1250" dirty="0"/>
           </a:p>
@@ -10822,7 +10822,7 @@
                 <a:ea typeface="Menlo" pitchFamily="34" charset="-122"/>
                 <a:cs typeface="Menlo" pitchFamily="34" charset="-120"/>
               </a:rPr>
-              <a:t>  + styles.css</a:t>
+              <a:t>  + style.css</a:t>
             </a:r>
             <a:endParaRPr lang="en-US" sz="1250" dirty="0"/>
           </a:p>
@@ -10842,7 +10842,7 @@
                 <a:ea typeface="Menlo" pitchFamily="34" charset="-122"/>
                 <a:cs typeface="Menlo" pitchFamily="34" charset="-120"/>
               </a:rPr>
-              <a:t>  + src/storage.js</a:t>
+              <a:t>  + script.js</a:t>
             </a:r>
             <a:endParaRPr lang="en-US" sz="1250" dirty="0"/>
           </a:p>
@@ -10862,7 +10862,7 @@
                 <a:ea typeface="Menlo" pitchFamily="34" charset="-122"/>
                 <a:cs typeface="Menlo" pitchFamily="34" charset="-120"/>
               </a:rPr>
-              <a:t>  + src/todo.js</a:t>
+              <a:t>  ✓ ブラウザで表示確認</a:t>
             </a:r>
             <a:endParaRPr lang="en-US" sz="1250" dirty="0"/>
           </a:p>
@@ -10876,13 +10876,13 @@
             <a:r>
               <a:rPr lang="en-US" sz="1250" dirty="0">
                 <a:solidFill>
-                  <a:srgbClr val="3FB950"/>
+                  <a:srgbClr val="C9D1D9"/>
                 </a:solidFill>
                 <a:latin typeface="Menlo" pitchFamily="34" charset="0"/>
                 <a:ea typeface="Menlo" pitchFamily="34" charset="-122"/>
                 <a:cs typeface="Menlo" pitchFamily="34" charset="-120"/>
               </a:rPr>
-              <a:t>  + src/app.js</a:t>
+              <a:t> </a:t>
             </a:r>
             <a:endParaRPr lang="en-US" sz="1250" dirty="0"/>
           </a:p>
@@ -10896,33 +10896,13 @@
             <a:r>
               <a:rPr lang="en-US" sz="1250" dirty="0">
                 <a:solidFill>
-                  <a:srgbClr val="C9D1D9"/>
+                  <a:srgbClr val="3FB950"/>
                 </a:solidFill>
                 <a:latin typeface="Menlo" pitchFamily="34" charset="0"/>
                 <a:ea typeface="Menlo" pitchFamily="34" charset="-122"/>
                 <a:cs typeface="Menlo" pitchFamily="34" charset="-120"/>
               </a:rPr>
-              <a:t> </a:t>
-            </a:r>
-            <a:endParaRPr lang="en-US" sz="1250" dirty="0"/>
-          </a:p>
-          <a:p>
-            <a:pPr algn="l" indent="0" marL="0">
-              <a:lnSpc>
-                <a:spcPct val="125000"/>
-              </a:lnSpc>
-              <a:buNone/>
-            </a:pPr>
-            <a:r>
-              <a:rPr lang="en-US" sz="1250" dirty="0">
-                <a:solidFill>
-                  <a:srgbClr val="3FB950"/>
-                </a:solidFill>
-                <a:latin typeface="Menlo" pitchFamily="34" charset="0"/>
-                <a:ea typeface="Menlo" pitchFamily="34" charset="-122"/>
-                <a:cs typeface="Menlo" pitchFamily="34" charset="-120"/>
-              </a:rPr>
-              <a:t>  ✓ 5ファイル作成</a:t>
+              <a:t>  ✓ 追加・完了・削除を確認</a:t>
             </a:r>
             <a:endParaRPr lang="en-US" sz="1250" dirty="0"/>
           </a:p>
@@ -11163,7 +11143,7 @@
                 <a:ea typeface="Hiragino Sans" pitchFamily="34" charset="-122"/>
                 <a:cs typeface="Hiragino Sans" pitchFamily="34" charset="-120"/>
               </a:rPr>
-              <a:t>STEP 6 ── ToDoアプリを作る</a:t>
+              <a:t>STEP 6 ── 作るものを決める</a:t>
             </a:r>
             <a:endParaRPr lang="en-US" sz="2900" dirty="0"/>
           </a:p>
@@ -11171,18 +11151,585 @@
       </p:sp>
       <p:sp>
         <p:nvSpPr>
-          <p:cNvPr id="5" name="Shape 3"/>
-          <p:cNvSpPr/>
-          <p:nvPr/>
-        </p:nvSpPr>
-        <p:spPr>
-          <a:xfrm>
-            <a:off x="640080" y="1920240"/>
-            <a:ext cx="5669280" cy="3886200"/>
+          <p:cNvPr id="5" name="Text 3"/>
+          <p:cNvSpPr/>
+          <p:nvPr/>
+        </p:nvSpPr>
+        <p:spPr>
+          <a:xfrm>
+            <a:off x="640080" y="1737360"/>
+            <a:ext cx="10908792" cy="411480"/>
+          </a:xfrm>
+          <a:prstGeom prst="rect">
+            <a:avLst/>
+          </a:prstGeom>
+          <a:noFill/>
+          <a:ln/>
+        </p:spPr>
+        <p:txBody>
+          <a:bodyPr wrap="square" lIns="0" tIns="0" rIns="0" bIns="0" rtlCol="0" anchor="ctr"/>
+          <a:lstStyle/>
+          <a:p>
+            <a:pPr algn="l" indent="0" marL="0">
+              <a:buNone/>
+            </a:pPr>
+            <a:r>
+              <a:rPr lang="en-US" sz="1600" dirty="0">
+                <a:solidFill>
+                  <a:srgbClr val="C9D1D9"/>
+                </a:solidFill>
+                <a:latin typeface="Hiragino Sans" pitchFamily="34" charset="0"/>
+                <a:ea typeface="Hiragino Sans" pitchFamily="34" charset="-122"/>
+                <a:cs typeface="Hiragino Sans" pitchFamily="34" charset="-120"/>
+              </a:rPr>
+              <a:t>今日は、ブラウザだけで動く ToDo ミニアプリを作ります。</a:t>
+            </a:r>
+            <a:endParaRPr lang="en-US" sz="1600" dirty="0"/>
+          </a:p>
+        </p:txBody>
+      </p:sp>
+      <p:sp>
+        <p:nvSpPr>
+          <p:cNvPr id="6" name="Shape 4"/>
+          <p:cNvSpPr/>
+          <p:nvPr/>
+        </p:nvSpPr>
+        <p:spPr>
+          <a:xfrm>
+            <a:off x="640080" y="2423160"/>
+            <a:ext cx="4572000" cy="749808"/>
           </a:xfrm>
           <a:prstGeom prst="roundRect">
             <a:avLst>
-              <a:gd name="adj" fmla="val 1412"/>
+              <a:gd name="adj" fmla="val 9756"/>
+            </a:avLst>
+          </a:prstGeom>
+          <a:solidFill>
+            <a:srgbClr val="161B22"/>
+          </a:solidFill>
+          <a:ln w="12700">
+            <a:solidFill>
+              <a:srgbClr val="30363D"/>
+            </a:solidFill>
+            <a:prstDash val="solid"/>
+          </a:ln>
+          <a:effectLst>
+            <a:outerShdw sx="100000" sy="100000" kx="0" ky="0" algn="bl" rotWithShape="0" blurRad="127000" dist="38100" dir="5400000">
+              <a:srgbClr val="000000">
+                <a:alpha val="35000"/>
+              </a:srgbClr>
+            </a:outerShdw>
+          </a:effectLst>
+        </p:spPr>
+      </p:sp>
+      <p:sp>
+        <p:nvSpPr>
+          <p:cNvPr id="7" name="Shape 5"/>
+          <p:cNvSpPr/>
+          <p:nvPr/>
+        </p:nvSpPr>
+        <p:spPr>
+          <a:xfrm>
+            <a:off x="640080" y="2423160"/>
+            <a:ext cx="82296" cy="749808"/>
+          </a:xfrm>
+          <a:prstGeom prst="rect">
+            <a:avLst/>
+          </a:prstGeom>
+          <a:solidFill>
+            <a:srgbClr val="3FB950"/>
+          </a:solidFill>
+          <a:ln/>
+        </p:spPr>
+      </p:sp>
+      <p:sp>
+        <p:nvSpPr>
+          <p:cNvPr id="8" name="Text 6"/>
+          <p:cNvSpPr/>
+          <p:nvPr/>
+        </p:nvSpPr>
+        <p:spPr>
+          <a:xfrm>
+            <a:off x="1005840" y="2514600"/>
+            <a:ext cx="3931920" cy="365760"/>
+          </a:xfrm>
+          <a:prstGeom prst="rect">
+            <a:avLst/>
+          </a:prstGeom>
+          <a:noFill/>
+          <a:ln/>
+        </p:spPr>
+        <p:txBody>
+          <a:bodyPr wrap="square" lIns="0" tIns="0" rIns="0" bIns="0" rtlCol="0" anchor="ctr"/>
+          <a:lstStyle/>
+          <a:p>
+            <a:pPr algn="l" indent="0" marL="0">
+              <a:buNone/>
+            </a:pPr>
+            <a:r>
+              <a:rPr lang="en-US" sz="1600" b="1" dirty="0">
+                <a:solidFill>
+                  <a:srgbClr val="E6EDF3"/>
+                </a:solidFill>
+                <a:latin typeface="Hiragino Sans" pitchFamily="34" charset="0"/>
+                <a:ea typeface="Hiragino Sans" pitchFamily="34" charset="-122"/>
+                <a:cs typeface="Hiragino Sans" pitchFamily="34" charset="-120"/>
+              </a:rPr>
+              <a:t>追加・完了・削除</a:t>
+            </a:r>
+            <a:endParaRPr lang="en-US" sz="1600" dirty="0"/>
+          </a:p>
+        </p:txBody>
+      </p:sp>
+      <p:sp>
+        <p:nvSpPr>
+          <p:cNvPr id="9" name="Text 7"/>
+          <p:cNvSpPr/>
+          <p:nvPr/>
+        </p:nvSpPr>
+        <p:spPr>
+          <a:xfrm>
+            <a:off x="1005840" y="2862072"/>
+            <a:ext cx="3931920" cy="292608"/>
+          </a:xfrm>
+          <a:prstGeom prst="rect">
+            <a:avLst/>
+          </a:prstGeom>
+          <a:noFill/>
+          <a:ln/>
+        </p:spPr>
+        <p:txBody>
+          <a:bodyPr wrap="square" lIns="0" tIns="0" rIns="0" bIns="0" rtlCol="0" anchor="ctr"/>
+          <a:lstStyle/>
+          <a:p>
+            <a:pPr algn="l" indent="0" marL="0">
+              <a:buNone/>
+            </a:pPr>
+            <a:r>
+              <a:rPr lang="en-US" sz="1250" dirty="0">
+                <a:solidFill>
+                  <a:srgbClr val="8B949E"/>
+                </a:solidFill>
+                <a:latin typeface="Hiragino Sans" pitchFamily="34" charset="0"/>
+                <a:ea typeface="Hiragino Sans" pitchFamily="34" charset="-122"/>
+                <a:cs typeface="Hiragino Sans" pitchFamily="34" charset="-120"/>
+              </a:rPr>
+              <a:t>基本操作がその場で試せる</a:t>
+            </a:r>
+            <a:endParaRPr lang="en-US" sz="1250" dirty="0"/>
+          </a:p>
+        </p:txBody>
+      </p:sp>
+      <p:sp>
+        <p:nvSpPr>
+          <p:cNvPr id="10" name="Shape 8"/>
+          <p:cNvSpPr/>
+          <p:nvPr/>
+        </p:nvSpPr>
+        <p:spPr>
+          <a:xfrm>
+            <a:off x="640080" y="3300984"/>
+            <a:ext cx="4572000" cy="749808"/>
+          </a:xfrm>
+          <a:prstGeom prst="roundRect">
+            <a:avLst>
+              <a:gd name="adj" fmla="val 9756"/>
+            </a:avLst>
+          </a:prstGeom>
+          <a:solidFill>
+            <a:srgbClr val="161B22"/>
+          </a:solidFill>
+          <a:ln w="12700">
+            <a:solidFill>
+              <a:srgbClr val="30363D"/>
+            </a:solidFill>
+            <a:prstDash val="solid"/>
+          </a:ln>
+          <a:effectLst>
+            <a:outerShdw sx="100000" sy="100000" kx="0" ky="0" algn="bl" rotWithShape="0" blurRad="127000" dist="38100" dir="5400000">
+              <a:srgbClr val="000000">
+                <a:alpha val="35000"/>
+              </a:srgbClr>
+            </a:outerShdw>
+          </a:effectLst>
+        </p:spPr>
+      </p:sp>
+      <p:sp>
+        <p:nvSpPr>
+          <p:cNvPr id="11" name="Shape 9"/>
+          <p:cNvSpPr/>
+          <p:nvPr/>
+        </p:nvSpPr>
+        <p:spPr>
+          <a:xfrm>
+            <a:off x="640080" y="3300984"/>
+            <a:ext cx="82296" cy="749808"/>
+          </a:xfrm>
+          <a:prstGeom prst="rect">
+            <a:avLst/>
+          </a:prstGeom>
+          <a:solidFill>
+            <a:srgbClr val="58A6FF"/>
+          </a:solidFill>
+          <a:ln/>
+        </p:spPr>
+      </p:sp>
+      <p:sp>
+        <p:nvSpPr>
+          <p:cNvPr id="12" name="Text 10"/>
+          <p:cNvSpPr/>
+          <p:nvPr/>
+        </p:nvSpPr>
+        <p:spPr>
+          <a:xfrm>
+            <a:off x="1005840" y="3392424"/>
+            <a:ext cx="3931920" cy="365760"/>
+          </a:xfrm>
+          <a:prstGeom prst="rect">
+            <a:avLst/>
+          </a:prstGeom>
+          <a:noFill/>
+          <a:ln/>
+        </p:spPr>
+        <p:txBody>
+          <a:bodyPr wrap="square" lIns="0" tIns="0" rIns="0" bIns="0" rtlCol="0" anchor="ctr"/>
+          <a:lstStyle/>
+          <a:p>
+            <a:pPr algn="l" indent="0" marL="0">
+              <a:buNone/>
+            </a:pPr>
+            <a:r>
+              <a:rPr lang="en-US" sz="1600" b="1" dirty="0">
+                <a:solidFill>
+                  <a:srgbClr val="E6EDF3"/>
+                </a:solidFill>
+                <a:latin typeface="Hiragino Sans" pitchFamily="34" charset="0"/>
+                <a:ea typeface="Hiragino Sans" pitchFamily="34" charset="-122"/>
+                <a:cs typeface="Hiragino Sans" pitchFamily="34" charset="-120"/>
+              </a:rPr>
+              <a:t>件数が見える</a:t>
+            </a:r>
+            <a:endParaRPr lang="en-US" sz="1600" dirty="0"/>
+          </a:p>
+        </p:txBody>
+      </p:sp>
+      <p:sp>
+        <p:nvSpPr>
+          <p:cNvPr id="13" name="Text 11"/>
+          <p:cNvSpPr/>
+          <p:nvPr/>
+        </p:nvSpPr>
+        <p:spPr>
+          <a:xfrm>
+            <a:off x="1005840" y="3739896"/>
+            <a:ext cx="3931920" cy="292608"/>
+          </a:xfrm>
+          <a:prstGeom prst="rect">
+            <a:avLst/>
+          </a:prstGeom>
+          <a:noFill/>
+          <a:ln/>
+        </p:spPr>
+        <p:txBody>
+          <a:bodyPr wrap="square" lIns="0" tIns="0" rIns="0" bIns="0" rtlCol="0" anchor="ctr"/>
+          <a:lstStyle/>
+          <a:p>
+            <a:pPr algn="l" indent="0" marL="0">
+              <a:buNone/>
+            </a:pPr>
+            <a:r>
+              <a:rPr lang="en-US" sz="1250" dirty="0">
+                <a:solidFill>
+                  <a:srgbClr val="8B949E"/>
+                </a:solidFill>
+                <a:latin typeface="Hiragino Sans" pitchFamily="34" charset="0"/>
+                <a:ea typeface="Hiragino Sans" pitchFamily="34" charset="-122"/>
+                <a:cs typeface="Hiragino Sans" pitchFamily="34" charset="-120"/>
+              </a:rPr>
+              <a:t>残り件数と完了件数を表示</a:t>
+            </a:r>
+            <a:endParaRPr lang="en-US" sz="1250" dirty="0"/>
+          </a:p>
+        </p:txBody>
+      </p:sp>
+      <p:sp>
+        <p:nvSpPr>
+          <p:cNvPr id="14" name="Shape 12"/>
+          <p:cNvSpPr/>
+          <p:nvPr/>
+        </p:nvSpPr>
+        <p:spPr>
+          <a:xfrm>
+            <a:off x="640080" y="4178808"/>
+            <a:ext cx="4572000" cy="749808"/>
+          </a:xfrm>
+          <a:prstGeom prst="roundRect">
+            <a:avLst>
+              <a:gd name="adj" fmla="val 9756"/>
+            </a:avLst>
+          </a:prstGeom>
+          <a:solidFill>
+            <a:srgbClr val="161B22"/>
+          </a:solidFill>
+          <a:ln w="12700">
+            <a:solidFill>
+              <a:srgbClr val="30363D"/>
+            </a:solidFill>
+            <a:prstDash val="solid"/>
+          </a:ln>
+          <a:effectLst>
+            <a:outerShdw sx="100000" sy="100000" kx="0" ky="0" algn="bl" rotWithShape="0" blurRad="127000" dist="38100" dir="5400000">
+              <a:srgbClr val="000000">
+                <a:alpha val="35000"/>
+              </a:srgbClr>
+            </a:outerShdw>
+          </a:effectLst>
+        </p:spPr>
+      </p:sp>
+      <p:sp>
+        <p:nvSpPr>
+          <p:cNvPr id="15" name="Shape 13"/>
+          <p:cNvSpPr/>
+          <p:nvPr/>
+        </p:nvSpPr>
+        <p:spPr>
+          <a:xfrm>
+            <a:off x="640080" y="4178808"/>
+            <a:ext cx="82296" cy="749808"/>
+          </a:xfrm>
+          <a:prstGeom prst="rect">
+            <a:avLst/>
+          </a:prstGeom>
+          <a:solidFill>
+            <a:srgbClr val="BC8CFF"/>
+          </a:solidFill>
+          <a:ln/>
+        </p:spPr>
+      </p:sp>
+      <p:sp>
+        <p:nvSpPr>
+          <p:cNvPr id="16" name="Text 14"/>
+          <p:cNvSpPr/>
+          <p:nvPr/>
+        </p:nvSpPr>
+        <p:spPr>
+          <a:xfrm>
+            <a:off x="1005840" y="4270248"/>
+            <a:ext cx="3931920" cy="365760"/>
+          </a:xfrm>
+          <a:prstGeom prst="rect">
+            <a:avLst/>
+          </a:prstGeom>
+          <a:noFill/>
+          <a:ln/>
+        </p:spPr>
+        <p:txBody>
+          <a:bodyPr wrap="square" lIns="0" tIns="0" rIns="0" bIns="0" rtlCol="0" anchor="ctr"/>
+          <a:lstStyle/>
+          <a:p>
+            <a:pPr algn="l" indent="0" marL="0">
+              <a:buNone/>
+            </a:pPr>
+            <a:r>
+              <a:rPr lang="en-US" sz="1600" b="1" dirty="0">
+                <a:solidFill>
+                  <a:srgbClr val="E6EDF3"/>
+                </a:solidFill>
+                <a:latin typeface="Hiragino Sans" pitchFamily="34" charset="0"/>
+                <a:ea typeface="Hiragino Sans" pitchFamily="34" charset="-122"/>
+                <a:cs typeface="Hiragino Sans" pitchFamily="34" charset="-120"/>
+              </a:rPr>
+              <a:t>閉じても残る</a:t>
+            </a:r>
+            <a:endParaRPr lang="en-US" sz="1600" dirty="0"/>
+          </a:p>
+        </p:txBody>
+      </p:sp>
+      <p:sp>
+        <p:nvSpPr>
+          <p:cNvPr id="17" name="Text 15"/>
+          <p:cNvSpPr/>
+          <p:nvPr/>
+        </p:nvSpPr>
+        <p:spPr>
+          <a:xfrm>
+            <a:off x="1005840" y="4617720"/>
+            <a:ext cx="3931920" cy="292608"/>
+          </a:xfrm>
+          <a:prstGeom prst="rect">
+            <a:avLst/>
+          </a:prstGeom>
+          <a:noFill/>
+          <a:ln/>
+        </p:spPr>
+        <p:txBody>
+          <a:bodyPr wrap="square" lIns="0" tIns="0" rIns="0" bIns="0" rtlCol="0" anchor="ctr"/>
+          <a:lstStyle/>
+          <a:p>
+            <a:pPr algn="l" indent="0" marL="0">
+              <a:buNone/>
+            </a:pPr>
+            <a:r>
+              <a:rPr lang="en-US" sz="1250" dirty="0">
+                <a:solidFill>
+                  <a:srgbClr val="8B949E"/>
+                </a:solidFill>
+                <a:latin typeface="Hiragino Sans" pitchFamily="34" charset="0"/>
+                <a:ea typeface="Hiragino Sans" pitchFamily="34" charset="-122"/>
+                <a:cs typeface="Hiragino Sans" pitchFamily="34" charset="-120"/>
+              </a:rPr>
+              <a:t>localStorage に保存</a:t>
+            </a:r>
+            <a:endParaRPr lang="en-US" sz="1250" dirty="0"/>
+          </a:p>
+        </p:txBody>
+      </p:sp>
+      <p:sp>
+        <p:nvSpPr>
+          <p:cNvPr id="18" name="Shape 16"/>
+          <p:cNvSpPr/>
+          <p:nvPr/>
+        </p:nvSpPr>
+        <p:spPr>
+          <a:xfrm>
+            <a:off x="640080" y="5056632"/>
+            <a:ext cx="4572000" cy="749808"/>
+          </a:xfrm>
+          <a:prstGeom prst="roundRect">
+            <a:avLst>
+              <a:gd name="adj" fmla="val 9756"/>
+            </a:avLst>
+          </a:prstGeom>
+          <a:solidFill>
+            <a:srgbClr val="161B22"/>
+          </a:solidFill>
+          <a:ln w="12700">
+            <a:solidFill>
+              <a:srgbClr val="30363D"/>
+            </a:solidFill>
+            <a:prstDash val="solid"/>
+          </a:ln>
+          <a:effectLst>
+            <a:outerShdw sx="100000" sy="100000" kx="0" ky="0" algn="bl" rotWithShape="0" blurRad="127000" dist="38100" dir="5400000">
+              <a:srgbClr val="000000">
+                <a:alpha val="35000"/>
+              </a:srgbClr>
+            </a:outerShdw>
+          </a:effectLst>
+        </p:spPr>
+      </p:sp>
+      <p:sp>
+        <p:nvSpPr>
+          <p:cNvPr id="19" name="Shape 17"/>
+          <p:cNvSpPr/>
+          <p:nvPr/>
+        </p:nvSpPr>
+        <p:spPr>
+          <a:xfrm>
+            <a:off x="640080" y="5056632"/>
+            <a:ext cx="82296" cy="749808"/>
+          </a:xfrm>
+          <a:prstGeom prst="rect">
+            <a:avLst/>
+          </a:prstGeom>
+          <a:solidFill>
+            <a:srgbClr val="F0883E"/>
+          </a:solidFill>
+          <a:ln/>
+        </p:spPr>
+      </p:sp>
+      <p:sp>
+        <p:nvSpPr>
+          <p:cNvPr id="20" name="Text 18"/>
+          <p:cNvSpPr/>
+          <p:nvPr/>
+        </p:nvSpPr>
+        <p:spPr>
+          <a:xfrm>
+            <a:off x="1005840" y="5148072"/>
+            <a:ext cx="3931920" cy="365760"/>
+          </a:xfrm>
+          <a:prstGeom prst="rect">
+            <a:avLst/>
+          </a:prstGeom>
+          <a:noFill/>
+          <a:ln/>
+        </p:spPr>
+        <p:txBody>
+          <a:bodyPr wrap="square" lIns="0" tIns="0" rIns="0" bIns="0" rtlCol="0" anchor="ctr"/>
+          <a:lstStyle/>
+          <a:p>
+            <a:pPr algn="l" indent="0" marL="0">
+              <a:buNone/>
+            </a:pPr>
+            <a:r>
+              <a:rPr lang="en-US" sz="1600" b="1" dirty="0">
+                <a:solidFill>
+                  <a:srgbClr val="E6EDF3"/>
+                </a:solidFill>
+                <a:latin typeface="Hiragino Sans" pitchFamily="34" charset="0"/>
+                <a:ea typeface="Hiragino Sans" pitchFamily="34" charset="-122"/>
+                <a:cs typeface="Hiragino Sans" pitchFamily="34" charset="-120"/>
+              </a:rPr>
+              <a:t>役割ごとに分ける</a:t>
+            </a:r>
+            <a:endParaRPr lang="en-US" sz="1600" dirty="0"/>
+          </a:p>
+        </p:txBody>
+      </p:sp>
+      <p:sp>
+        <p:nvSpPr>
+          <p:cNvPr id="21" name="Text 19"/>
+          <p:cNvSpPr/>
+          <p:nvPr/>
+        </p:nvSpPr>
+        <p:spPr>
+          <a:xfrm>
+            <a:off x="1005840" y="5495544"/>
+            <a:ext cx="3931920" cy="292608"/>
+          </a:xfrm>
+          <a:prstGeom prst="rect">
+            <a:avLst/>
+          </a:prstGeom>
+          <a:noFill/>
+          <a:ln/>
+        </p:spPr>
+        <p:txBody>
+          <a:bodyPr wrap="square" lIns="0" tIns="0" rIns="0" bIns="0" rtlCol="0" anchor="ctr"/>
+          <a:lstStyle/>
+          <a:p>
+            <a:pPr algn="l" indent="0" marL="0">
+              <a:buNone/>
+            </a:pPr>
+            <a:r>
+              <a:rPr lang="en-US" sz="1250" dirty="0">
+                <a:solidFill>
+                  <a:srgbClr val="8B949E"/>
+                </a:solidFill>
+                <a:latin typeface="Hiragino Sans" pitchFamily="34" charset="0"/>
+                <a:ea typeface="Hiragino Sans" pitchFamily="34" charset="-122"/>
+                <a:cs typeface="Hiragino Sans" pitchFamily="34" charset="-120"/>
+              </a:rPr>
+              <a:t>画面・見た目・動きを読みやすく</a:t>
+            </a:r>
+            <a:endParaRPr lang="en-US" sz="1250" dirty="0"/>
+          </a:p>
+        </p:txBody>
+      </p:sp>
+      <p:sp>
+        <p:nvSpPr>
+          <p:cNvPr id="22" name="Shape 20"/>
+          <p:cNvSpPr/>
+          <p:nvPr/>
+        </p:nvSpPr>
+        <p:spPr>
+          <a:xfrm>
+            <a:off x="5577840" y="2331720"/>
+            <a:ext cx="5989320" cy="3520440"/>
+          </a:xfrm>
+          <a:prstGeom prst="roundRect">
+            <a:avLst>
+              <a:gd name="adj" fmla="val 2078"/>
             </a:avLst>
           </a:prstGeom>
           <a:solidFill>
@@ -11205,14 +11752,14 @@
       </p:sp>
       <p:sp>
         <p:nvSpPr>
-          <p:cNvPr id="6" name="Shape 4"/>
-          <p:cNvSpPr/>
-          <p:nvPr/>
-        </p:nvSpPr>
-        <p:spPr>
-          <a:xfrm>
-            <a:off x="649224" y="1929384"/>
-            <a:ext cx="5650992" cy="347472"/>
+          <p:cNvPr id="23" name="Shape 21"/>
+          <p:cNvSpPr/>
+          <p:nvPr/>
+        </p:nvSpPr>
+        <p:spPr>
+          <a:xfrm>
+            <a:off x="5577840" y="2331720"/>
+            <a:ext cx="5989320" cy="384048"/>
           </a:xfrm>
           <a:prstGeom prst="rect">
             <a:avLst/>
@@ -11225,13 +11772,13 @@
       </p:sp>
       <p:sp>
         <p:nvSpPr>
-          <p:cNvPr id="7" name="Shape 5"/>
-          <p:cNvSpPr/>
-          <p:nvPr/>
-        </p:nvSpPr>
-        <p:spPr>
-          <a:xfrm>
-            <a:off x="804672" y="2043684"/>
+          <p:cNvPr id="24" name="Shape 22"/>
+          <p:cNvSpPr/>
+          <p:nvPr/>
+        </p:nvSpPr>
+        <p:spPr>
+          <a:xfrm>
+            <a:off x="5760720" y="2478024"/>
             <a:ext cx="109728" cy="109728"/>
           </a:xfrm>
           <a:prstGeom prst="ellipse">
@@ -11245,13 +11792,13 @@
       </p:sp>
       <p:sp>
         <p:nvSpPr>
-          <p:cNvPr id="8" name="Shape 6"/>
-          <p:cNvSpPr/>
-          <p:nvPr/>
-        </p:nvSpPr>
-        <p:spPr>
-          <a:xfrm>
-            <a:off x="1005840" y="2043684"/>
+          <p:cNvPr id="25" name="Shape 23"/>
+          <p:cNvSpPr/>
+          <p:nvPr/>
+        </p:nvSpPr>
+        <p:spPr>
+          <a:xfrm>
+            <a:off x="5961888" y="2478024"/>
             <a:ext cx="109728" cy="109728"/>
           </a:xfrm>
           <a:prstGeom prst="ellipse">
@@ -11265,13 +11812,13 @@
       </p:sp>
       <p:sp>
         <p:nvSpPr>
-          <p:cNvPr id="9" name="Shape 7"/>
-          <p:cNvSpPr/>
-          <p:nvPr/>
-        </p:nvSpPr>
-        <p:spPr>
-          <a:xfrm>
-            <a:off x="1207008" y="2043684"/>
+          <p:cNvPr id="26" name="Shape 24"/>
+          <p:cNvSpPr/>
+          <p:nvPr/>
+        </p:nvSpPr>
+        <p:spPr>
+          <a:xfrm>
+            <a:off x="6163056" y="2478024"/>
             <a:ext cx="109728" cy="109728"/>
           </a:xfrm>
           <a:prstGeom prst="ellipse">
@@ -11285,30 +11832,30 @@
       </p:sp>
       <p:sp>
         <p:nvSpPr>
-          <p:cNvPr id="10" name="Text 8"/>
-          <p:cNvSpPr/>
-          <p:nvPr/>
-        </p:nvSpPr>
-        <p:spPr>
-          <a:xfrm>
-            <a:off x="1463040" y="1929384"/>
-            <a:ext cx="4572000" cy="347472"/>
-          </a:xfrm>
-          <a:prstGeom prst="rect">
-            <a:avLst/>
-          </a:prstGeom>
-          <a:noFill/>
-          <a:ln/>
-        </p:spPr>
-        <p:txBody>
-          <a:bodyPr wrap="square" lIns="0" tIns="0" rIns="0" bIns="0" rtlCol="0" anchor="ctr"/>
-          <a:lstStyle/>
-          <a:p>
-            <a:pPr algn="l" indent="0" marL="0">
-              <a:buNone/>
-            </a:pPr>
-            <a:r>
-              <a:rPr lang="en-US" sz="1000" dirty="0">
+          <p:cNvPr id="27" name="Text 25"/>
+          <p:cNvSpPr/>
+          <p:nvPr/>
+        </p:nvSpPr>
+        <p:spPr>
+          <a:xfrm>
+            <a:off x="6446520" y="2331720"/>
+            <a:ext cx="4846320" cy="384048"/>
+          </a:xfrm>
+          <a:prstGeom prst="rect">
+            <a:avLst/>
+          </a:prstGeom>
+          <a:noFill/>
+          <a:ln/>
+        </p:spPr>
+        <p:txBody>
+          <a:bodyPr wrap="square" lIns="0" tIns="0" rIns="0" bIns="0" rtlCol="0" anchor="ctr"/>
+          <a:lstStyle/>
+          <a:p>
+            <a:pPr algn="l" indent="0" marL="0">
+              <a:buNone/>
+            </a:pPr>
+            <a:r>
+              <a:rPr lang="en-US" sz="1100" dirty="0">
                 <a:solidFill>
                   <a:srgbClr val="8B949E"/>
                 </a:solidFill>
@@ -11316,744 +11863,39 @@
                 <a:ea typeface="Menlo" pitchFamily="34" charset="-122"/>
                 <a:cs typeface="Menlo" pitchFamily="34" charset="-120"/>
               </a:rPr>
-              <a:t>エージェントが作る構成（例）</a:t>
-            </a:r>
-            <a:endParaRPr lang="en-US" sz="1000" dirty="0"/>
-          </a:p>
-        </p:txBody>
-      </p:sp>
-      <p:sp>
-        <p:nvSpPr>
-          <p:cNvPr id="11" name="Text 9"/>
-          <p:cNvSpPr/>
-          <p:nvPr/>
-        </p:nvSpPr>
-        <p:spPr>
-          <a:xfrm>
-            <a:off x="896112" y="2377440"/>
-            <a:ext cx="5212080" cy="3319272"/>
-          </a:xfrm>
-          <a:prstGeom prst="rect">
-            <a:avLst/>
-          </a:prstGeom>
-          <a:noFill/>
-          <a:ln/>
-        </p:spPr>
-        <p:txBody>
-          <a:bodyPr wrap="square" lIns="0" tIns="0" rIns="0" bIns="0" rtlCol="0" anchor="t"/>
-          <a:lstStyle/>
-          <a:p>
-            <a:pPr algn="l" indent="0" marL="0">
-              <a:lnSpc>
-                <a:spcPct val="125000"/>
-              </a:lnSpc>
-              <a:buNone/>
-            </a:pPr>
-            <a:r>
-              <a:rPr lang="en-US" sz="1400" dirty="0">
-                <a:solidFill>
-                  <a:srgbClr val="8B949E"/>
-                </a:solidFill>
-                <a:latin typeface="Menlo" pitchFamily="34" charset="0"/>
-                <a:ea typeface="Menlo" pitchFamily="34" charset="-122"/>
-                <a:cs typeface="Menlo" pitchFamily="34" charset="-120"/>
-              </a:rPr>
-              <a:t>todo-app/</a:t>
-            </a:r>
-            <a:endParaRPr lang="en-US" sz="1400" dirty="0"/>
-          </a:p>
-          <a:p>
-            <a:pPr algn="l" indent="0" marL="0">
-              <a:lnSpc>
-                <a:spcPct val="125000"/>
-              </a:lnSpc>
-              <a:buNone/>
-            </a:pPr>
-            <a:r>
-              <a:rPr lang="en-US" sz="1400" dirty="0">
-                <a:solidFill>
-                  <a:srgbClr val="C9D1D9"/>
-                </a:solidFill>
-                <a:latin typeface="Menlo" pitchFamily="34" charset="0"/>
-                <a:ea typeface="Menlo" pitchFamily="34" charset="-122"/>
-                <a:cs typeface="Menlo" pitchFamily="34" charset="-120"/>
-              </a:rPr>
-              <a:t>  index.html     画面</a:t>
-            </a:r>
-            <a:endParaRPr lang="en-US" sz="1400" dirty="0"/>
-          </a:p>
-          <a:p>
-            <a:pPr algn="l" indent="0" marL="0">
-              <a:lnSpc>
-                <a:spcPct val="125000"/>
-              </a:lnSpc>
-              <a:buNone/>
-            </a:pPr>
-            <a:r>
-              <a:rPr lang="en-US" sz="1400" dirty="0">
-                <a:solidFill>
-                  <a:srgbClr val="C9D1D9"/>
-                </a:solidFill>
-                <a:latin typeface="Menlo" pitchFamily="34" charset="0"/>
-                <a:ea typeface="Menlo" pitchFamily="34" charset="-122"/>
-                <a:cs typeface="Menlo" pitchFamily="34" charset="-120"/>
-              </a:rPr>
-              <a:t>  styles.css     見た目</a:t>
-            </a:r>
-            <a:endParaRPr lang="en-US" sz="1400" dirty="0"/>
-          </a:p>
-          <a:p>
-            <a:pPr algn="l" indent="0" marL="0">
-              <a:lnSpc>
-                <a:spcPct val="125000"/>
-              </a:lnSpc>
-              <a:buNone/>
-            </a:pPr>
-            <a:r>
-              <a:rPr lang="en-US" sz="1400" dirty="0">
-                <a:solidFill>
-                  <a:srgbClr val="8B949E"/>
-                </a:solidFill>
-                <a:latin typeface="Menlo" pitchFamily="34" charset="0"/>
-                <a:ea typeface="Menlo" pitchFamily="34" charset="-122"/>
-                <a:cs typeface="Menlo" pitchFamily="34" charset="-120"/>
-              </a:rPr>
-              <a:t>  src/</a:t>
-            </a:r>
-            <a:endParaRPr lang="en-US" sz="1400" dirty="0"/>
-          </a:p>
-          <a:p>
-            <a:pPr algn="l" indent="0" marL="0">
-              <a:lnSpc>
-                <a:spcPct val="125000"/>
-              </a:lnSpc>
-              <a:buNone/>
-            </a:pPr>
-            <a:r>
-              <a:rPr lang="en-US" sz="1400" dirty="0">
-                <a:solidFill>
-                  <a:srgbClr val="C9D1D9"/>
-                </a:solidFill>
-                <a:latin typeface="Menlo" pitchFamily="34" charset="0"/>
-                <a:ea typeface="Menlo" pitchFamily="34" charset="-122"/>
-                <a:cs typeface="Menlo" pitchFamily="34" charset="-120"/>
-              </a:rPr>
-              <a:t>    storage.js   保存（localStorage）</a:t>
-            </a:r>
-            <a:endParaRPr lang="en-US" sz="1400" dirty="0"/>
-          </a:p>
-          <a:p>
-            <a:pPr algn="l" indent="0" marL="0">
-              <a:lnSpc>
-                <a:spcPct val="125000"/>
-              </a:lnSpc>
-              <a:buNone/>
-            </a:pPr>
-            <a:r>
-              <a:rPr lang="en-US" sz="1400" dirty="0">
-                <a:solidFill>
-                  <a:srgbClr val="C9D1D9"/>
-                </a:solidFill>
-                <a:latin typeface="Menlo" pitchFamily="34" charset="0"/>
-                <a:ea typeface="Menlo" pitchFamily="34" charset="-122"/>
-                <a:cs typeface="Menlo" pitchFamily="34" charset="-120"/>
-              </a:rPr>
-              <a:t>    todo.js      追加・完了・削除</a:t>
-            </a:r>
-            <a:endParaRPr lang="en-US" sz="1400" dirty="0"/>
-          </a:p>
-          <a:p>
-            <a:pPr algn="l" indent="0" marL="0">
-              <a:lnSpc>
-                <a:spcPct val="125000"/>
-              </a:lnSpc>
-              <a:buNone/>
-            </a:pPr>
-            <a:r>
-              <a:rPr lang="en-US" sz="1400" dirty="0">
-                <a:solidFill>
-                  <a:srgbClr val="C9D1D9"/>
-                </a:solidFill>
-                <a:latin typeface="Menlo" pitchFamily="34" charset="0"/>
-                <a:ea typeface="Menlo" pitchFamily="34" charset="-122"/>
-                <a:cs typeface="Menlo" pitchFamily="34" charset="-120"/>
-              </a:rPr>
-              <a:t>    app.js       画面とロジックの入口</a:t>
-            </a:r>
-            <a:endParaRPr lang="en-US" sz="1400" dirty="0"/>
-          </a:p>
-        </p:txBody>
-      </p:sp>
-      <p:sp>
-        <p:nvSpPr>
-          <p:cNvPr id="12" name="Shape 10"/>
-          <p:cNvSpPr/>
-          <p:nvPr/>
-        </p:nvSpPr>
-        <p:spPr>
-          <a:xfrm>
-            <a:off x="6675120" y="1920240"/>
-            <a:ext cx="4846320" cy="749808"/>
-          </a:xfrm>
-          <a:prstGeom prst="roundRect">
-            <a:avLst>
-              <a:gd name="adj" fmla="val 9756"/>
-            </a:avLst>
-          </a:prstGeom>
-          <a:solidFill>
-            <a:srgbClr val="161B22"/>
-          </a:solidFill>
-          <a:ln w="12700">
-            <a:solidFill>
-              <a:srgbClr val="30363D"/>
-            </a:solidFill>
-            <a:prstDash val="solid"/>
-          </a:ln>
-          <a:effectLst>
-            <a:outerShdw sx="100000" sy="100000" kx="0" ky="0" algn="bl" rotWithShape="0" blurRad="127000" dist="38100" dir="5400000">
-              <a:srgbClr val="000000">
-                <a:alpha val="35000"/>
-              </a:srgbClr>
-            </a:outerShdw>
-          </a:effectLst>
-        </p:spPr>
-      </p:sp>
-      <p:sp>
-        <p:nvSpPr>
-          <p:cNvPr id="13" name="Shape 11"/>
-          <p:cNvSpPr/>
-          <p:nvPr/>
-        </p:nvSpPr>
-        <p:spPr>
-          <a:xfrm>
-            <a:off x="6675120" y="1920240"/>
-            <a:ext cx="82296" cy="749808"/>
-          </a:xfrm>
-          <a:prstGeom prst="rect">
-            <a:avLst/>
-          </a:prstGeom>
-          <a:solidFill>
-            <a:srgbClr val="3FB950"/>
-          </a:solidFill>
-          <a:ln/>
-        </p:spPr>
-      </p:sp>
-      <p:sp>
-        <p:nvSpPr>
-          <p:cNvPr id="14" name="Text 12"/>
-          <p:cNvSpPr/>
-          <p:nvPr/>
-        </p:nvSpPr>
-        <p:spPr>
-          <a:xfrm>
-            <a:off x="7040880" y="2011680"/>
-            <a:ext cx="4206240" cy="365760"/>
-          </a:xfrm>
-          <a:prstGeom prst="rect">
-            <a:avLst/>
-          </a:prstGeom>
-          <a:noFill/>
-          <a:ln/>
-        </p:spPr>
-        <p:txBody>
-          <a:bodyPr wrap="square" lIns="0" tIns="0" rIns="0" bIns="0" rtlCol="0" anchor="ctr"/>
-          <a:lstStyle/>
-          <a:p>
-            <a:pPr algn="l" indent="0" marL="0">
-              <a:buNone/>
-            </a:pPr>
-            <a:r>
-              <a:rPr lang="en-US" sz="1600" b="1" dirty="0">
-                <a:solidFill>
-                  <a:srgbClr val="E6EDF3"/>
-                </a:solidFill>
-                <a:latin typeface="Hiragino Sans" pitchFamily="34" charset="0"/>
-                <a:ea typeface="Hiragino Sans" pitchFamily="34" charset="-122"/>
-                <a:cs typeface="Hiragino Sans" pitchFamily="34" charset="-120"/>
-              </a:rPr>
-              <a:t>タスクを追加</a:t>
-            </a:r>
-            <a:endParaRPr lang="en-US" sz="1600" dirty="0"/>
-          </a:p>
-        </p:txBody>
-      </p:sp>
-      <p:sp>
-        <p:nvSpPr>
-          <p:cNvPr id="15" name="Text 13"/>
-          <p:cNvSpPr/>
-          <p:nvPr/>
-        </p:nvSpPr>
-        <p:spPr>
-          <a:xfrm>
-            <a:off x="7040880" y="2359152"/>
-            <a:ext cx="4206240" cy="292608"/>
-          </a:xfrm>
-          <a:prstGeom prst="rect">
-            <a:avLst/>
-          </a:prstGeom>
-          <a:noFill/>
-          <a:ln/>
-        </p:spPr>
-        <p:txBody>
-          <a:bodyPr wrap="square" lIns="0" tIns="0" rIns="0" bIns="0" rtlCol="0" anchor="ctr"/>
-          <a:lstStyle/>
-          <a:p>
-            <a:pPr algn="l" indent="0" marL="0">
-              <a:buNone/>
-            </a:pPr>
-            <a:r>
-              <a:rPr lang="en-US" sz="1250" dirty="0">
-                <a:solidFill>
-                  <a:srgbClr val="8B949E"/>
-                </a:solidFill>
-                <a:latin typeface="Hiragino Sans" pitchFamily="34" charset="0"/>
-                <a:ea typeface="Hiragino Sans" pitchFamily="34" charset="-122"/>
-                <a:cs typeface="Hiragino Sans" pitchFamily="34" charset="-120"/>
-              </a:rPr>
-              <a:t>入力して「追加」で登録</a:t>
-            </a:r>
-            <a:endParaRPr lang="en-US" sz="1250" dirty="0"/>
-          </a:p>
-        </p:txBody>
-      </p:sp>
-      <p:sp>
-        <p:nvSpPr>
-          <p:cNvPr id="16" name="Shape 14"/>
-          <p:cNvSpPr/>
-          <p:nvPr/>
-        </p:nvSpPr>
-        <p:spPr>
-          <a:xfrm>
-            <a:off x="6675120" y="2798064"/>
-            <a:ext cx="4846320" cy="749808"/>
-          </a:xfrm>
-          <a:prstGeom prst="roundRect">
-            <a:avLst>
-              <a:gd name="adj" fmla="val 9756"/>
-            </a:avLst>
-          </a:prstGeom>
-          <a:solidFill>
-            <a:srgbClr val="161B22"/>
-          </a:solidFill>
-          <a:ln w="12700">
-            <a:solidFill>
-              <a:srgbClr val="30363D"/>
-            </a:solidFill>
-            <a:prstDash val="solid"/>
-          </a:ln>
-          <a:effectLst>
-            <a:outerShdw sx="100000" sy="100000" kx="0" ky="0" algn="bl" rotWithShape="0" blurRad="127000" dist="38100" dir="5400000">
-              <a:srgbClr val="000000">
-                <a:alpha val="35000"/>
-              </a:srgbClr>
-            </a:outerShdw>
-          </a:effectLst>
-        </p:spPr>
-      </p:sp>
-      <p:sp>
-        <p:nvSpPr>
-          <p:cNvPr id="17" name="Shape 15"/>
-          <p:cNvSpPr/>
-          <p:nvPr/>
-        </p:nvSpPr>
-        <p:spPr>
-          <a:xfrm>
-            <a:off x="6675120" y="2798064"/>
-            <a:ext cx="82296" cy="749808"/>
-          </a:xfrm>
-          <a:prstGeom prst="rect">
-            <a:avLst/>
-          </a:prstGeom>
-          <a:solidFill>
-            <a:srgbClr val="58A6FF"/>
-          </a:solidFill>
-          <a:ln/>
-        </p:spPr>
-      </p:sp>
-      <p:sp>
-        <p:nvSpPr>
-          <p:cNvPr id="18" name="Text 16"/>
-          <p:cNvSpPr/>
-          <p:nvPr/>
-        </p:nvSpPr>
-        <p:spPr>
-          <a:xfrm>
-            <a:off x="7040880" y="2889504"/>
-            <a:ext cx="4206240" cy="365760"/>
-          </a:xfrm>
-          <a:prstGeom prst="rect">
-            <a:avLst/>
-          </a:prstGeom>
-          <a:noFill/>
-          <a:ln/>
-        </p:spPr>
-        <p:txBody>
-          <a:bodyPr wrap="square" lIns="0" tIns="0" rIns="0" bIns="0" rtlCol="0" anchor="ctr"/>
-          <a:lstStyle/>
-          <a:p>
-            <a:pPr algn="l" indent="0" marL="0">
-              <a:buNone/>
-            </a:pPr>
-            <a:r>
-              <a:rPr lang="en-US" sz="1600" b="1" dirty="0">
-                <a:solidFill>
-                  <a:srgbClr val="E6EDF3"/>
-                </a:solidFill>
-                <a:latin typeface="Hiragino Sans" pitchFamily="34" charset="0"/>
-                <a:ea typeface="Hiragino Sans" pitchFamily="34" charset="-122"/>
-                <a:cs typeface="Hiragino Sans" pitchFamily="34" charset="-120"/>
-              </a:rPr>
-              <a:t>完了でチェック</a:t>
-            </a:r>
-            <a:endParaRPr lang="en-US" sz="1600" dirty="0"/>
-          </a:p>
-        </p:txBody>
-      </p:sp>
-      <p:sp>
-        <p:nvSpPr>
-          <p:cNvPr id="19" name="Text 17"/>
-          <p:cNvSpPr/>
-          <p:nvPr/>
-        </p:nvSpPr>
-        <p:spPr>
-          <a:xfrm>
-            <a:off x="7040880" y="3236976"/>
-            <a:ext cx="4206240" cy="292608"/>
-          </a:xfrm>
-          <a:prstGeom prst="rect">
-            <a:avLst/>
-          </a:prstGeom>
-          <a:noFill/>
-          <a:ln/>
-        </p:spPr>
-        <p:txBody>
-          <a:bodyPr wrap="square" lIns="0" tIns="0" rIns="0" bIns="0" rtlCol="0" anchor="ctr"/>
-          <a:lstStyle/>
-          <a:p>
-            <a:pPr algn="l" indent="0" marL="0">
-              <a:buNone/>
-            </a:pPr>
-            <a:r>
-              <a:rPr lang="en-US" sz="1250" dirty="0">
-                <a:solidFill>
-                  <a:srgbClr val="8B949E"/>
-                </a:solidFill>
-                <a:latin typeface="Hiragino Sans" pitchFamily="34" charset="0"/>
-                <a:ea typeface="Hiragino Sans" pitchFamily="34" charset="-122"/>
-                <a:cs typeface="Hiragino Sans" pitchFamily="34" charset="-120"/>
-              </a:rPr>
-              <a:t>押すと打ち消し線が付く</a:t>
-            </a:r>
-            <a:endParaRPr lang="en-US" sz="1250" dirty="0"/>
-          </a:p>
-        </p:txBody>
-      </p:sp>
-      <p:sp>
-        <p:nvSpPr>
-          <p:cNvPr id="20" name="Shape 18"/>
-          <p:cNvSpPr/>
-          <p:nvPr/>
-        </p:nvSpPr>
-        <p:spPr>
-          <a:xfrm>
-            <a:off x="6675120" y="3675888"/>
-            <a:ext cx="4846320" cy="749808"/>
-          </a:xfrm>
-          <a:prstGeom prst="roundRect">
-            <a:avLst>
-              <a:gd name="adj" fmla="val 9756"/>
-            </a:avLst>
-          </a:prstGeom>
-          <a:solidFill>
-            <a:srgbClr val="161B22"/>
-          </a:solidFill>
-          <a:ln w="12700">
-            <a:solidFill>
-              <a:srgbClr val="30363D"/>
-            </a:solidFill>
-            <a:prstDash val="solid"/>
-          </a:ln>
-          <a:effectLst>
-            <a:outerShdw sx="100000" sy="100000" kx="0" ky="0" algn="bl" rotWithShape="0" blurRad="127000" dist="38100" dir="5400000">
-              <a:srgbClr val="000000">
-                <a:alpha val="35000"/>
-              </a:srgbClr>
-            </a:outerShdw>
-          </a:effectLst>
-        </p:spPr>
-      </p:sp>
-      <p:sp>
-        <p:nvSpPr>
-          <p:cNvPr id="21" name="Shape 19"/>
-          <p:cNvSpPr/>
-          <p:nvPr/>
-        </p:nvSpPr>
-        <p:spPr>
-          <a:xfrm>
-            <a:off x="6675120" y="3675888"/>
-            <a:ext cx="82296" cy="749808"/>
-          </a:xfrm>
-          <a:prstGeom prst="rect">
-            <a:avLst/>
-          </a:prstGeom>
-          <a:solidFill>
-            <a:srgbClr val="BC8CFF"/>
-          </a:solidFill>
-          <a:ln/>
-        </p:spPr>
-      </p:sp>
-      <p:sp>
-        <p:nvSpPr>
-          <p:cNvPr id="22" name="Text 20"/>
-          <p:cNvSpPr/>
-          <p:nvPr/>
-        </p:nvSpPr>
-        <p:spPr>
-          <a:xfrm>
-            <a:off x="7040880" y="3767328"/>
-            <a:ext cx="4206240" cy="365760"/>
-          </a:xfrm>
-          <a:prstGeom prst="rect">
-            <a:avLst/>
-          </a:prstGeom>
-          <a:noFill/>
-          <a:ln/>
-        </p:spPr>
-        <p:txBody>
-          <a:bodyPr wrap="square" lIns="0" tIns="0" rIns="0" bIns="0" rtlCol="0" anchor="ctr"/>
-          <a:lstStyle/>
-          <a:p>
-            <a:pPr algn="l" indent="0" marL="0">
-              <a:buNone/>
-            </a:pPr>
-            <a:r>
-              <a:rPr lang="en-US" sz="1600" b="1" dirty="0">
-                <a:solidFill>
-                  <a:srgbClr val="E6EDF3"/>
-                </a:solidFill>
-                <a:latin typeface="Hiragino Sans" pitchFamily="34" charset="0"/>
-                <a:ea typeface="Hiragino Sans" pitchFamily="34" charset="-122"/>
-                <a:cs typeface="Hiragino Sans" pitchFamily="34" charset="-120"/>
-              </a:rPr>
-              <a:t>いらないものは削除</a:t>
-            </a:r>
-            <a:endParaRPr lang="en-US" sz="1600" dirty="0"/>
-          </a:p>
-        </p:txBody>
-      </p:sp>
-      <p:sp>
-        <p:nvSpPr>
-          <p:cNvPr id="23" name="Text 21"/>
-          <p:cNvSpPr/>
-          <p:nvPr/>
-        </p:nvSpPr>
-        <p:spPr>
-          <a:xfrm>
-            <a:off x="7040880" y="4114800"/>
-            <a:ext cx="4206240" cy="292608"/>
-          </a:xfrm>
-          <a:prstGeom prst="rect">
-            <a:avLst/>
-          </a:prstGeom>
-          <a:noFill/>
-          <a:ln/>
-        </p:spPr>
-        <p:txBody>
-          <a:bodyPr wrap="square" lIns="0" tIns="0" rIns="0" bIns="0" rtlCol="0" anchor="ctr"/>
-          <a:lstStyle/>
-          <a:p>
-            <a:pPr algn="l" indent="0" marL="0">
-              <a:buNone/>
-            </a:pPr>
-            <a:r>
-              <a:rPr lang="en-US" sz="1250" dirty="0">
-                <a:solidFill>
-                  <a:srgbClr val="8B949E"/>
-                </a:solidFill>
-                <a:latin typeface="Hiragino Sans" pitchFamily="34" charset="0"/>
-                <a:ea typeface="Hiragino Sans" pitchFamily="34" charset="-122"/>
-                <a:cs typeface="Hiragino Sans" pitchFamily="34" charset="-120"/>
-              </a:rPr>
-              <a:t>× ボタンで消える</a:t>
-            </a:r>
-            <a:endParaRPr lang="en-US" sz="1250" dirty="0"/>
-          </a:p>
-        </p:txBody>
-      </p:sp>
-      <p:sp>
-        <p:nvSpPr>
-          <p:cNvPr id="24" name="Shape 22"/>
-          <p:cNvSpPr/>
-          <p:nvPr/>
-        </p:nvSpPr>
-        <p:spPr>
-          <a:xfrm>
-            <a:off x="6675120" y="4553712"/>
-            <a:ext cx="4846320" cy="749808"/>
-          </a:xfrm>
-          <a:prstGeom prst="roundRect">
-            <a:avLst>
-              <a:gd name="adj" fmla="val 9756"/>
-            </a:avLst>
-          </a:prstGeom>
-          <a:solidFill>
-            <a:srgbClr val="161B22"/>
-          </a:solidFill>
-          <a:ln w="12700">
-            <a:solidFill>
-              <a:srgbClr val="30363D"/>
-            </a:solidFill>
-            <a:prstDash val="solid"/>
-          </a:ln>
-          <a:effectLst>
-            <a:outerShdw sx="100000" sy="100000" kx="0" ky="0" algn="bl" rotWithShape="0" blurRad="127000" dist="38100" dir="5400000">
-              <a:srgbClr val="000000">
-                <a:alpha val="35000"/>
-              </a:srgbClr>
-            </a:outerShdw>
-          </a:effectLst>
-        </p:spPr>
-      </p:sp>
-      <p:sp>
-        <p:nvSpPr>
-          <p:cNvPr id="25" name="Shape 23"/>
-          <p:cNvSpPr/>
-          <p:nvPr/>
-        </p:nvSpPr>
-        <p:spPr>
-          <a:xfrm>
-            <a:off x="6675120" y="4553712"/>
-            <a:ext cx="82296" cy="749808"/>
-          </a:xfrm>
-          <a:prstGeom prst="rect">
-            <a:avLst/>
-          </a:prstGeom>
-          <a:solidFill>
-            <a:srgbClr val="F0883E"/>
-          </a:solidFill>
-          <a:ln/>
-        </p:spPr>
-      </p:sp>
-      <p:sp>
-        <p:nvSpPr>
-          <p:cNvPr id="26" name="Text 24"/>
-          <p:cNvSpPr/>
-          <p:nvPr/>
-        </p:nvSpPr>
-        <p:spPr>
-          <a:xfrm>
-            <a:off x="7040880" y="4645152"/>
-            <a:ext cx="4206240" cy="365760"/>
-          </a:xfrm>
-          <a:prstGeom prst="rect">
-            <a:avLst/>
-          </a:prstGeom>
-          <a:noFill/>
-          <a:ln/>
-        </p:spPr>
-        <p:txBody>
-          <a:bodyPr wrap="square" lIns="0" tIns="0" rIns="0" bIns="0" rtlCol="0" anchor="ctr"/>
-          <a:lstStyle/>
-          <a:p>
-            <a:pPr algn="l" indent="0" marL="0">
-              <a:buNone/>
-            </a:pPr>
-            <a:r>
-              <a:rPr lang="en-US" sz="1600" b="1" dirty="0">
-                <a:solidFill>
-                  <a:srgbClr val="E6EDF3"/>
-                </a:solidFill>
-                <a:latin typeface="Hiragino Sans" pitchFamily="34" charset="0"/>
-                <a:ea typeface="Hiragino Sans" pitchFamily="34" charset="-122"/>
-                <a:cs typeface="Hiragino Sans" pitchFamily="34" charset="-120"/>
-              </a:rPr>
-              <a:t>閉じても残る</a:t>
-            </a:r>
-            <a:endParaRPr lang="en-US" sz="1600" dirty="0"/>
-          </a:p>
-        </p:txBody>
-      </p:sp>
-      <p:sp>
-        <p:nvSpPr>
-          <p:cNvPr id="27" name="Text 25"/>
-          <p:cNvSpPr/>
-          <p:nvPr/>
-        </p:nvSpPr>
-        <p:spPr>
-          <a:xfrm>
-            <a:off x="7040880" y="4992624"/>
-            <a:ext cx="4206240" cy="292608"/>
-          </a:xfrm>
-          <a:prstGeom prst="rect">
-            <a:avLst/>
-          </a:prstGeom>
-          <a:noFill/>
-          <a:ln/>
-        </p:spPr>
-        <p:txBody>
-          <a:bodyPr wrap="square" lIns="0" tIns="0" rIns="0" bIns="0" rtlCol="0" anchor="ctr"/>
-          <a:lstStyle/>
-          <a:p>
-            <a:pPr algn="l" indent="0" marL="0">
-              <a:buNone/>
-            </a:pPr>
-            <a:r>
-              <a:rPr lang="en-US" sz="1250" dirty="0">
-                <a:solidFill>
-                  <a:srgbClr val="8B949E"/>
-                </a:solidFill>
-                <a:latin typeface="Hiragino Sans" pitchFamily="34" charset="0"/>
-                <a:ea typeface="Hiragino Sans" pitchFamily="34" charset="-122"/>
-                <a:cs typeface="Hiragino Sans" pitchFamily="34" charset="-120"/>
-              </a:rPr>
-              <a:t>localStorage に保存</a:t>
-            </a:r>
-            <a:endParaRPr lang="en-US" sz="1250" dirty="0"/>
-          </a:p>
-        </p:txBody>
-      </p:sp>
-      <p:sp>
-        <p:nvSpPr>
-          <p:cNvPr id="28" name="Text 26"/>
-          <p:cNvSpPr/>
-          <p:nvPr/>
-        </p:nvSpPr>
-        <p:spPr>
-          <a:xfrm>
-            <a:off x="6675120" y="5532120"/>
-            <a:ext cx="4846320" cy="274320"/>
-          </a:xfrm>
-          <a:prstGeom prst="rect">
-            <a:avLst/>
-          </a:prstGeom>
-          <a:noFill/>
-          <a:ln/>
-        </p:spPr>
-        <p:txBody>
-          <a:bodyPr wrap="square" lIns="0" tIns="0" rIns="0" bIns="0" rtlCol="0" anchor="ctr"/>
-          <a:lstStyle/>
-          <a:p>
-            <a:pPr algn="l" indent="0" marL="0">
-              <a:buNone/>
-            </a:pPr>
-            <a:r>
-              <a:rPr lang="en-US" sz="1250" dirty="0">
-                <a:solidFill>
-                  <a:srgbClr val="3FB950"/>
-                </a:solidFill>
-                <a:latin typeface="Hiragino Sans" pitchFamily="34" charset="0"/>
-                <a:ea typeface="Hiragino Sans" pitchFamily="34" charset="-122"/>
-                <a:cs typeface="Hiragino Sans" pitchFamily="34" charset="-120"/>
-              </a:rPr>
-              <a:t>どう分けるかも、まとめてエージェントが考えてくれます。</a:t>
-            </a:r>
-            <a:endParaRPr lang="en-US" sz="1250" dirty="0"/>
-          </a:p>
-        </p:txBody>
-      </p:sp>
-      <p:sp>
-        <p:nvSpPr>
-          <p:cNvPr id="29" name="Text 27"/>
+              <a:t>opencode で生成した実物</a:t>
+            </a:r>
+            <a:endParaRPr lang="en-US" sz="1100" dirty="0"/>
+          </a:p>
+        </p:txBody>
+      </p:sp>
+      <p:pic>
+        <p:nvPicPr>
+          <p:cNvPr id="28" name="Image 0" descr="/Users/ojii3/src/github.com/OJII3/opencode_openrouter_free_example/slides/assets/todo-hands-on-screenshot.png">    </p:cNvPr>
+          <p:cNvPicPr>
+            <a:picLocks noChangeAspect="1"/>
+          </p:cNvPicPr>
+          <p:nvPr/>
+        </p:nvPicPr>
+        <p:blipFill>
+          <a:blip r:embed="rId1"/>
+          <a:stretch>
+            <a:fillRect/>
+          </a:stretch>
+        </p:blipFill>
+        <p:spPr>
+          <a:xfrm>
+            <a:off x="5779008" y="2889504"/>
+            <a:ext cx="5577840" cy="2697480"/>
+          </a:xfrm>
+          <a:prstGeom prst="rect">
+            <a:avLst/>
+          </a:prstGeom>
+        </p:spPr>
+      </p:pic>
+      <p:sp>
+        <p:nvSpPr>
+          <p:cNvPr id="29" name="Text 26"/>
           <p:cNvSpPr/>
           <p:nvPr/>
         </p:nvSpPr>
@@ -12106,7 +11948,7 @@
       </p:sp>
       <p:sp>
         <p:nvSpPr>
-          <p:cNvPr id="30" name="Text 28"/>
+          <p:cNvPr id="30" name="Text 27"/>
           <p:cNvSpPr/>
           <p:nvPr/>
         </p:nvSpPr>
@@ -12286,7 +12128,7 @@
                 <a:ea typeface="Hiragino Sans" pitchFamily="34" charset="-122"/>
                 <a:cs typeface="Hiragino Sans" pitchFamily="34" charset="-120"/>
               </a:rPr>
-              <a:t>プロンプトはシンプルでいい</a:t>
+              <a:t>このプロンプトを貼る</a:t>
             </a:r>
             <a:endParaRPr lang="en-US" sz="2900" dirty="0"/>
           </a:p>
@@ -12294,57 +12136,18 @@
       </p:sp>
       <p:sp>
         <p:nvSpPr>
-          <p:cNvPr id="5" name="Text 3"/>
-          <p:cNvSpPr/>
-          <p:nvPr/>
-        </p:nvSpPr>
-        <p:spPr>
-          <a:xfrm>
-            <a:off x="640080" y="1783080"/>
-            <a:ext cx="10908792" cy="457200"/>
-          </a:xfrm>
-          <a:prstGeom prst="rect">
-            <a:avLst/>
-          </a:prstGeom>
-          <a:noFill/>
-          <a:ln/>
-        </p:spPr>
-        <p:txBody>
-          <a:bodyPr wrap="square" lIns="0" tIns="0" rIns="0" bIns="0" rtlCol="0" anchor="ctr"/>
-          <a:lstStyle/>
-          <a:p>
-            <a:pPr algn="l" indent="0" marL="0">
-              <a:buNone/>
-            </a:pPr>
-            <a:r>
-              <a:rPr lang="en-US" sz="1600" dirty="0">
-                <a:solidFill>
-                  <a:srgbClr val="C9D1D9"/>
-                </a:solidFill>
-                <a:latin typeface="Hiragino Sans" pitchFamily="34" charset="0"/>
-                <a:ea typeface="Hiragino Sans" pitchFamily="34" charset="-122"/>
-                <a:cs typeface="Hiragino Sans" pitchFamily="34" charset="-120"/>
-              </a:rPr>
-              <a:t>「作りたいもの」と「こうなってほしい」を伝えるだけ。作り方はエージェントが考えます。</a:t>
-            </a:r>
-            <a:endParaRPr lang="en-US" sz="1600" dirty="0"/>
-          </a:p>
-        </p:txBody>
-      </p:sp>
-      <p:sp>
-        <p:nvSpPr>
-          <p:cNvPr id="6" name="Shape 4"/>
-          <p:cNvSpPr/>
-          <p:nvPr/>
-        </p:nvSpPr>
-        <p:spPr>
-          <a:xfrm>
-            <a:off x="640080" y="2468880"/>
-            <a:ext cx="10908792" cy="2514600"/>
+          <p:cNvPr id="5" name="Shape 3"/>
+          <p:cNvSpPr/>
+          <p:nvPr/>
+        </p:nvSpPr>
+        <p:spPr>
+          <a:xfrm>
+            <a:off x="640080" y="1581912"/>
+            <a:ext cx="10908792" cy="4096512"/>
           </a:xfrm>
           <a:prstGeom prst="roundRect">
             <a:avLst>
-              <a:gd name="adj" fmla="val 2182"/>
+              <a:gd name="adj" fmla="val 1339"/>
             </a:avLst>
           </a:prstGeom>
           <a:solidFill>
@@ -12367,13 +12170,13 @@
       </p:sp>
       <p:sp>
         <p:nvSpPr>
-          <p:cNvPr id="7" name="Shape 5"/>
-          <p:cNvSpPr/>
-          <p:nvPr/>
-        </p:nvSpPr>
-        <p:spPr>
-          <a:xfrm>
-            <a:off x="649224" y="2478024"/>
+          <p:cNvPr id="6" name="Shape 4"/>
+          <p:cNvSpPr/>
+          <p:nvPr/>
+        </p:nvSpPr>
+        <p:spPr>
+          <a:xfrm>
+            <a:off x="649224" y="1591056"/>
             <a:ext cx="10890504" cy="347472"/>
           </a:xfrm>
           <a:prstGeom prst="rect">
@@ -12387,13 +12190,13 @@
       </p:sp>
       <p:sp>
         <p:nvSpPr>
-          <p:cNvPr id="8" name="Shape 6"/>
-          <p:cNvSpPr/>
-          <p:nvPr/>
-        </p:nvSpPr>
-        <p:spPr>
-          <a:xfrm>
-            <a:off x="804672" y="2592324"/>
+          <p:cNvPr id="7" name="Shape 5"/>
+          <p:cNvSpPr/>
+          <p:nvPr/>
+        </p:nvSpPr>
+        <p:spPr>
+          <a:xfrm>
+            <a:off x="804672" y="1705356"/>
             <a:ext cx="109728" cy="109728"/>
           </a:xfrm>
           <a:prstGeom prst="ellipse">
@@ -12407,13 +12210,13 @@
       </p:sp>
       <p:sp>
         <p:nvSpPr>
-          <p:cNvPr id="9" name="Shape 7"/>
-          <p:cNvSpPr/>
-          <p:nvPr/>
-        </p:nvSpPr>
-        <p:spPr>
-          <a:xfrm>
-            <a:off x="1005840" y="2592324"/>
+          <p:cNvPr id="8" name="Shape 6"/>
+          <p:cNvSpPr/>
+          <p:nvPr/>
+        </p:nvSpPr>
+        <p:spPr>
+          <a:xfrm>
+            <a:off x="1005840" y="1705356"/>
             <a:ext cx="109728" cy="109728"/>
           </a:xfrm>
           <a:prstGeom prst="ellipse">
@@ -12427,13 +12230,13 @@
       </p:sp>
       <p:sp>
         <p:nvSpPr>
-          <p:cNvPr id="10" name="Shape 8"/>
-          <p:cNvSpPr/>
-          <p:nvPr/>
-        </p:nvSpPr>
-        <p:spPr>
-          <a:xfrm>
-            <a:off x="1207008" y="2592324"/>
+          <p:cNvPr id="9" name="Shape 7"/>
+          <p:cNvSpPr/>
+          <p:nvPr/>
+        </p:nvSpPr>
+        <p:spPr>
+          <a:xfrm>
+            <a:off x="1207008" y="1705356"/>
             <a:ext cx="109728" cy="109728"/>
           </a:xfrm>
           <a:prstGeom prst="ellipse">
@@ -12447,13 +12250,13 @@
       </p:sp>
       <p:sp>
         <p:nvSpPr>
-          <p:cNvPr id="11" name="Text 9"/>
-          <p:cNvSpPr/>
-          <p:nvPr/>
-        </p:nvSpPr>
-        <p:spPr>
-          <a:xfrm>
-            <a:off x="1463040" y="2478024"/>
+          <p:cNvPr id="10" name="Text 8"/>
+          <p:cNvSpPr/>
+          <p:nvPr/>
+        </p:nvSpPr>
+        <p:spPr>
+          <a:xfrm>
+            <a:off x="1463040" y="1591056"/>
             <a:ext cx="9811512" cy="347472"/>
           </a:xfrm>
           <a:prstGeom prst="rect">
@@ -12486,14 +12289,14 @@
       </p:sp>
       <p:sp>
         <p:nvSpPr>
-          <p:cNvPr id="12" name="Text 10"/>
-          <p:cNvSpPr/>
-          <p:nvPr/>
-        </p:nvSpPr>
-        <p:spPr>
-          <a:xfrm>
-            <a:off x="896112" y="2926080"/>
-            <a:ext cx="10451592" cy="1947672"/>
+          <p:cNvPr id="11" name="Text 9"/>
+          <p:cNvSpPr/>
+          <p:nvPr/>
+        </p:nvSpPr>
+        <p:spPr>
+          <a:xfrm>
+            <a:off x="896112" y="2039112"/>
+            <a:ext cx="10451592" cy="3529584"/>
           </a:xfrm>
           <a:prstGeom prst="rect">
             <a:avLst/>
@@ -12512,7 +12315,7 @@
               <a:buNone/>
             </a:pPr>
             <a:r>
-              <a:rPr lang="en-US" sz="1500" dirty="0">
+              <a:rPr lang="en-US" sz="1000" dirty="0">
                 <a:solidFill>
                   <a:srgbClr val="E6EDF3"/>
                 </a:solidFill>
@@ -12520,9 +12323,9 @@
                 <a:ea typeface="Menlo" pitchFamily="34" charset="-122"/>
                 <a:cs typeface="Menlo" pitchFamily="34" charset="-120"/>
               </a:rPr>
-              <a:t>ToDoアプリを作って。</a:t>
-            </a:r>
-            <a:endParaRPr lang="en-US" sz="1500" dirty="0"/>
+              <a:t>ブラウザで動くミニToDoアプリを作ってください。</a:t>
+            </a:r>
+            <a:endParaRPr lang="en-US" sz="1000" dirty="0"/>
           </a:p>
           <a:p>
             <a:pPr algn="l" indent="0" marL="0">
@@ -12532,7 +12335,7 @@
               <a:buNone/>
             </a:pPr>
             <a:r>
-              <a:rPr lang="en-US" sz="1500" dirty="0">
+              <a:rPr lang="en-US" sz="1000" dirty="0">
                 <a:solidFill>
                   <a:srgbClr val="C9D1D9"/>
                 </a:solidFill>
@@ -12540,9 +12343,9 @@
                 <a:ea typeface="Menlo" pitchFamily="34" charset="-122"/>
                 <a:cs typeface="Menlo" pitchFamily="34" charset="-120"/>
               </a:rPr>
-              <a:t>・タスクの追加・完了チェック・削除ができる</a:t>
-            </a:r>
-            <a:endParaRPr lang="en-US" sz="1500" dirty="0"/>
+              <a:t>- タスクの追加、完了切り替え、削除ができる</a:t>
+            </a:r>
+            <a:endParaRPr lang="en-US" sz="1000" dirty="0"/>
           </a:p>
           <a:p>
             <a:pPr algn="l" indent="0" marL="0">
@@ -12552,7 +12355,7 @@
               <a:buNone/>
             </a:pPr>
             <a:r>
-              <a:rPr lang="en-US" sz="1500" dirty="0">
+              <a:rPr lang="en-US" sz="1000" dirty="0">
                 <a:solidFill>
                   <a:srgbClr val="C9D1D9"/>
                 </a:solidFill>
@@ -12560,9 +12363,9 @@
                 <a:ea typeface="Menlo" pitchFamily="34" charset="-122"/>
                 <a:cs typeface="Menlo" pitchFamily="34" charset="-120"/>
               </a:rPr>
-              <a:t>・閉じても内容が残るようにする</a:t>
-            </a:r>
-            <a:endParaRPr lang="en-US" sz="1500" dirty="0"/>
+              <a:t>- 残り件数と完了件数を表示する</a:t>
+            </a:r>
+            <a:endParaRPr lang="en-US" sz="1000" dirty="0"/>
           </a:p>
           <a:p>
             <a:pPr algn="l" indent="0" marL="0">
@@ -12572,7 +12375,7 @@
               <a:buNone/>
             </a:pPr>
             <a:r>
-              <a:rPr lang="en-US" sz="1500" dirty="0">
+              <a:rPr lang="en-US" sz="1000" dirty="0">
                 <a:solidFill>
                   <a:srgbClr val="C9D1D9"/>
                 </a:solidFill>
@@ -12580,9 +12383,9 @@
                 <a:ea typeface="Menlo" pitchFamily="34" charset="-122"/>
                 <a:cs typeface="Menlo" pitchFamily="34" charset="-120"/>
               </a:rPr>
-              <a:t>・コードは役割ごとに複数のファイルに分ける</a:t>
-            </a:r>
-            <a:endParaRPr lang="en-US" sz="1500" dirty="0"/>
+              <a:t>- localStorage に保存し、再読み込み後も残る</a:t>
+            </a:r>
+            <a:endParaRPr lang="en-US" sz="1000" dirty="0"/>
           </a:p>
           <a:p>
             <a:pPr algn="l" indent="0" marL="0">
@@ -12592,7 +12395,7 @@
               <a:buNone/>
             </a:pPr>
             <a:r>
-              <a:rPr lang="en-US" sz="1500" dirty="0">
+              <a:rPr lang="en-US" sz="1000" dirty="0">
                 <a:solidFill>
                   <a:srgbClr val="C9D1D9"/>
                 </a:solidFill>
@@ -12600,26 +12403,226 @@
                 <a:ea typeface="Menlo" pitchFamily="34" charset="-122"/>
                 <a:cs typeface="Menlo" pitchFamily="34" charset="-120"/>
               </a:rPr>
-              <a:t>・見た目もシンプルに整える</a:t>
-            </a:r>
-            <a:endParaRPr lang="en-US" sz="1500" dirty="0"/>
-          </a:p>
-        </p:txBody>
-      </p:sp>
-      <p:sp>
-        <p:nvSpPr>
-          <p:cNvPr id="13" name="Shape 11"/>
-          <p:cNvSpPr/>
-          <p:nvPr/>
-        </p:nvSpPr>
-        <p:spPr>
-          <a:xfrm>
-            <a:off x="640080" y="5166360"/>
-            <a:ext cx="10908792" cy="868680"/>
+              <a:t>- 初回表示時はサンプルタスクを3件入れる</a:t>
+            </a:r>
+            <a:endParaRPr lang="en-US" sz="1000" dirty="0"/>
+          </a:p>
+          <a:p>
+            <a:pPr algn="l" indent="0" marL="0">
+              <a:lnSpc>
+                <a:spcPct val="125000"/>
+              </a:lnSpc>
+              <a:buNone/>
+            </a:pPr>
+            <a:r>
+              <a:rPr lang="en-US" sz="1000" dirty="0">
+                <a:solidFill>
+                  <a:srgbClr val="C9D1D9"/>
+                </a:solidFill>
+                <a:latin typeface="Menlo" pitchFamily="34" charset="0"/>
+                <a:ea typeface="Menlo" pitchFamily="34" charset="-122"/>
+                <a:cs typeface="Menlo" pitchFamily="34" charset="-120"/>
+              </a:rPr>
+              <a:t>- スマホでもPCでも見やすいカード風の見た目</a:t>
+            </a:r>
+            <a:endParaRPr lang="en-US" sz="1000" dirty="0"/>
+          </a:p>
+          <a:p>
+            <a:pPr algn="l" indent="0" marL="0">
+              <a:lnSpc>
+                <a:spcPct val="125000"/>
+              </a:lnSpc>
+              <a:buNone/>
+            </a:pPr>
+            <a:r>
+              <a:rPr lang="en-US" sz="1000" dirty="0">
+                <a:solidFill>
+                  <a:srgbClr val="C9D1D9"/>
+                </a:solidFill>
+                <a:latin typeface="Menlo" pitchFamily="34" charset="0"/>
+                <a:ea typeface="Menlo" pitchFamily="34" charset="-122"/>
+                <a:cs typeface="Menlo" pitchFamily="34" charset="-120"/>
+              </a:rPr>
+              <a:t> </a:t>
+            </a:r>
+            <a:endParaRPr lang="en-US" sz="1000" dirty="0"/>
+          </a:p>
+          <a:p>
+            <a:pPr algn="l" indent="0" marL="0">
+              <a:lnSpc>
+                <a:spcPct val="125000"/>
+              </a:lnSpc>
+              <a:buNone/>
+            </a:pPr>
+            <a:r>
+              <a:rPr lang="en-US" sz="1000" dirty="0">
+                <a:solidFill>
+                  <a:srgbClr val="F0883E"/>
+                </a:solidFill>
+                <a:latin typeface="Menlo" pitchFamily="34" charset="0"/>
+                <a:ea typeface="Menlo" pitchFamily="34" charset="-122"/>
+                <a:cs typeface="Menlo" pitchFamily="34" charset="-120"/>
+              </a:rPr>
+              <a:t>実装条件:</a:t>
+            </a:r>
+            <a:endParaRPr lang="en-US" sz="1000" dirty="0"/>
+          </a:p>
+          <a:p>
+            <a:pPr algn="l" indent="0" marL="0">
+              <a:lnSpc>
+                <a:spcPct val="125000"/>
+              </a:lnSpc>
+              <a:buNone/>
+            </a:pPr>
+            <a:r>
+              <a:rPr lang="en-US" sz="1000" dirty="0">
+                <a:solidFill>
+                  <a:srgbClr val="C9D1D9"/>
+                </a:solidFill>
+                <a:latin typeface="Menlo" pitchFamily="34" charset="0"/>
+                <a:ea typeface="Menlo" pitchFamily="34" charset="-122"/>
+                <a:cs typeface="Menlo" pitchFamily="34" charset="-120"/>
+              </a:rPr>
+              <a:t>- HTML / CSS / JavaScript を役割ごとに分ける</a:t>
+            </a:r>
+            <a:endParaRPr lang="en-US" sz="1000" dirty="0"/>
+          </a:p>
+          <a:p>
+            <a:pPr algn="l" indent="0" marL="0">
+              <a:lnSpc>
+                <a:spcPct val="125000"/>
+              </a:lnSpc>
+              <a:buNone/>
+            </a:pPr>
+            <a:r>
+              <a:rPr lang="en-US" sz="1000" dirty="0">
+                <a:solidFill>
+                  <a:srgbClr val="C9D1D9"/>
+                </a:solidFill>
+                <a:latin typeface="Menlo" pitchFamily="34" charset="0"/>
+                <a:ea typeface="Menlo" pitchFamily="34" charset="-122"/>
+                <a:cs typeface="Menlo" pitchFamily="34" charset="-120"/>
+              </a:rPr>
+              <a:t>- 作ったファイルと確認手順を最後に教える</a:t>
+            </a:r>
+            <a:endParaRPr lang="en-US" sz="1000" dirty="0"/>
+          </a:p>
+          <a:p>
+            <a:pPr algn="l" indent="0" marL="0">
+              <a:lnSpc>
+                <a:spcPct val="125000"/>
+              </a:lnSpc>
+              <a:buNone/>
+            </a:pPr>
+            <a:r>
+              <a:rPr lang="en-US" sz="1000" dirty="0">
+                <a:solidFill>
+                  <a:srgbClr val="C9D1D9"/>
+                </a:solidFill>
+                <a:latin typeface="Menlo" pitchFamily="34" charset="0"/>
+                <a:ea typeface="Menlo" pitchFamily="34" charset="-122"/>
+                <a:cs typeface="Menlo" pitchFamily="34" charset="-120"/>
+              </a:rPr>
+              <a:t> </a:t>
+            </a:r>
+            <a:endParaRPr lang="en-US" sz="1000" dirty="0"/>
+          </a:p>
+          <a:p>
+            <a:pPr algn="l" indent="0" marL="0">
+              <a:lnSpc>
+                <a:spcPct val="125000"/>
+              </a:lnSpc>
+              <a:buNone/>
+            </a:pPr>
+            <a:r>
+              <a:rPr lang="en-US" sz="1000" dirty="0">
+                <a:solidFill>
+                  <a:srgbClr val="F0883E"/>
+                </a:solidFill>
+                <a:latin typeface="Menlo" pitchFamily="34" charset="0"/>
+                <a:ea typeface="Menlo" pitchFamily="34" charset="-122"/>
+                <a:cs typeface="Menlo" pitchFamily="34" charset="-120"/>
+              </a:rPr>
+              <a:t>確認すること:</a:t>
+            </a:r>
+            <a:endParaRPr lang="en-US" sz="1000" dirty="0"/>
+          </a:p>
+          <a:p>
+            <a:pPr algn="l" indent="0" marL="0">
+              <a:lnSpc>
+                <a:spcPct val="125000"/>
+              </a:lnSpc>
+              <a:buNone/>
+            </a:pPr>
+            <a:r>
+              <a:rPr lang="en-US" sz="1000" dirty="0">
+                <a:solidFill>
+                  <a:srgbClr val="C9D1D9"/>
+                </a:solidFill>
+                <a:latin typeface="Menlo" pitchFamily="34" charset="0"/>
+                <a:ea typeface="Menlo" pitchFamily="34" charset="-122"/>
+                <a:cs typeface="Menlo" pitchFamily="34" charset="-120"/>
+              </a:rPr>
+              <a:t>- 追加・完了切り替え・削除・再読み込み後の保存</a:t>
+            </a:r>
+            <a:endParaRPr lang="en-US" sz="1000" dirty="0"/>
+          </a:p>
+          <a:p>
+            <a:pPr algn="l" indent="0" marL="0">
+              <a:lnSpc>
+                <a:spcPct val="125000"/>
+              </a:lnSpc>
+              <a:buNone/>
+            </a:pPr>
+            <a:r>
+              <a:rPr lang="en-US" sz="1000" dirty="0">
+                <a:solidFill>
+                  <a:srgbClr val="3FB950"/>
+                </a:solidFill>
+                <a:latin typeface="Menlo" pitchFamily="34" charset="0"/>
+                <a:ea typeface="Menlo" pitchFamily="34" charset="-122"/>
+                <a:cs typeface="Menlo" pitchFamily="34" charset="-120"/>
+              </a:rPr>
+              <a:t>python3 -m http.server 8000 で起動して確認し、</a:t>
+            </a:r>
+            <a:endParaRPr lang="en-US" sz="1000" dirty="0"/>
+          </a:p>
+          <a:p>
+            <a:pPr algn="l" indent="0" marL="0">
+              <a:lnSpc>
+                <a:spcPct val="125000"/>
+              </a:lnSpc>
+              <a:buNone/>
+            </a:pPr>
+            <a:r>
+              <a:rPr lang="en-US" sz="1000" dirty="0">
+                <a:solidFill>
+                  <a:srgbClr val="3FB950"/>
+                </a:solidFill>
+                <a:latin typeface="Menlo" pitchFamily="34" charset="0"/>
+                <a:ea typeface="Menlo" pitchFamily="34" charset="-122"/>
+                <a:cs typeface="Menlo" pitchFamily="34" charset="-120"/>
+              </a:rPr>
+              <a:t>問題があれば修正してください。</a:t>
+            </a:r>
+            <a:endParaRPr lang="en-US" sz="1000" dirty="0"/>
+          </a:p>
+        </p:txBody>
+      </p:sp>
+      <p:sp>
+        <p:nvSpPr>
+          <p:cNvPr id="12" name="Shape 10"/>
+          <p:cNvSpPr/>
+          <p:nvPr/>
+        </p:nvSpPr>
+        <p:spPr>
+          <a:xfrm>
+            <a:off x="640080" y="5760720"/>
+            <a:ext cx="10908792" cy="411480"/>
           </a:xfrm>
           <a:prstGeom prst="roundRect">
             <a:avLst>
-              <a:gd name="adj" fmla="val 8421"/>
+              <a:gd name="adj" fmla="val 17778"/>
             </a:avLst>
           </a:prstGeom>
           <a:solidFill>
@@ -12642,14 +12645,14 @@
       </p:sp>
       <p:sp>
         <p:nvSpPr>
-          <p:cNvPr id="14" name="Shape 12"/>
-          <p:cNvSpPr/>
-          <p:nvPr/>
-        </p:nvSpPr>
-        <p:spPr>
-          <a:xfrm>
-            <a:off x="640080" y="5166360"/>
-            <a:ext cx="82296" cy="868680"/>
+          <p:cNvPr id="13" name="Shape 11"/>
+          <p:cNvSpPr/>
+          <p:nvPr/>
+        </p:nvSpPr>
+        <p:spPr>
+          <a:xfrm>
+            <a:off x="640080" y="5760720"/>
+            <a:ext cx="82296" cy="411480"/>
           </a:xfrm>
           <a:prstGeom prst="rect">
             <a:avLst/>
@@ -12662,60 +12665,60 @@
       </p:sp>
       <p:sp>
         <p:nvSpPr>
+          <p:cNvPr id="14" name="Text 12"/>
+          <p:cNvSpPr/>
+          <p:nvPr/>
+        </p:nvSpPr>
+        <p:spPr>
+          <a:xfrm>
+            <a:off x="1005840" y="5760720"/>
+            <a:ext cx="10268712" cy="411480"/>
+          </a:xfrm>
+          <a:prstGeom prst="rect">
+            <a:avLst/>
+          </a:prstGeom>
+          <a:noFill/>
+          <a:ln/>
+        </p:spPr>
+        <p:txBody>
+          <a:bodyPr wrap="square" lIns="0" tIns="0" rIns="0" bIns="0" rtlCol="0" anchor="ctr"/>
+          <a:lstStyle/>
+          <a:p>
+            <a:pPr algn="l" indent="0" marL="0">
+              <a:buNone/>
+            </a:pPr>
+            <a:r>
+              <a:rPr lang="en-US" sz="1300" b="1" dirty="0">
+                <a:solidFill>
+                  <a:srgbClr val="E6EDF3"/>
+                </a:solidFill>
+                <a:latin typeface="Hiragino Sans" pitchFamily="34" charset="0"/>
+                <a:ea typeface="Hiragino Sans" pitchFamily="34" charset="-122"/>
+                <a:cs typeface="Hiragino Sans" pitchFamily="34" charset="-120"/>
+              </a:rPr>
+              <a:t>ポイント：</a:t>
+            </a:r>
+            <a:pPr algn="l" indent="0" marL="0">
+              <a:buNone/>
+            </a:pPr>
+            <a:r>
+              <a:rPr lang="en-US" sz="1300" dirty="0">
+                <a:solidFill>
+                  <a:srgbClr val="C9D1D9"/>
+                </a:solidFill>
+                <a:latin typeface="Hiragino Sans" pitchFamily="34" charset="0"/>
+                <a:ea typeface="Hiragino Sans" pitchFamily="34" charset="-122"/>
+                <a:cs typeface="Hiragino Sans" pitchFamily="34" charset="-120"/>
+              </a:rPr>
+              <a:t> 完成条件まで書くと無料モデルでも安定。役割と成功条件を渡す。</a:t>
+            </a:r>
+            <a:endParaRPr lang="en-US" sz="1300" dirty="0"/>
+          </a:p>
+        </p:txBody>
+      </p:sp>
+      <p:sp>
+        <p:nvSpPr>
           <p:cNvPr id="15" name="Text 13"/>
-          <p:cNvSpPr/>
-          <p:nvPr/>
-        </p:nvSpPr>
-        <p:spPr>
-          <a:xfrm>
-            <a:off x="1005840" y="5166360"/>
-            <a:ext cx="10268712" cy="868680"/>
-          </a:xfrm>
-          <a:prstGeom prst="rect">
-            <a:avLst/>
-          </a:prstGeom>
-          <a:noFill/>
-          <a:ln/>
-        </p:spPr>
-        <p:txBody>
-          <a:bodyPr wrap="square" lIns="0" tIns="0" rIns="0" bIns="0" rtlCol="0" anchor="ctr"/>
-          <a:lstStyle/>
-          <a:p>
-            <a:pPr algn="l" indent="0" marL="0">
-              <a:buNone/>
-            </a:pPr>
-            <a:r>
-              <a:rPr lang="en-US" sz="1500" b="1" dirty="0">
-                <a:solidFill>
-                  <a:srgbClr val="E6EDF3"/>
-                </a:solidFill>
-                <a:latin typeface="Hiragino Sans" pitchFamily="34" charset="0"/>
-                <a:ea typeface="Hiragino Sans" pitchFamily="34" charset="-122"/>
-                <a:cs typeface="Hiragino Sans" pitchFamily="34" charset="-120"/>
-              </a:rPr>
-              <a:t>ファイル名や分け方までは指定しなくてOK。</a:t>
-            </a:r>
-            <a:pPr algn="l" indent="0" marL="0">
-              <a:buNone/>
-            </a:pPr>
-            <a:r>
-              <a:rPr lang="en-US" sz="1500" dirty="0">
-                <a:solidFill>
-                  <a:srgbClr val="C9D1D9"/>
-                </a:solidFill>
-                <a:latin typeface="Hiragino Sans" pitchFamily="34" charset="0"/>
-                <a:ea typeface="Hiragino Sans" pitchFamily="34" charset="-122"/>
-                <a:cs typeface="Hiragino Sans" pitchFamily="34" charset="-120"/>
-              </a:rPr>
-              <a:t> どう作るかはエージェントが判断します。</a:t>
-            </a:r>
-            <a:endParaRPr lang="en-US" sz="1500" dirty="0"/>
-          </a:p>
-        </p:txBody>
-      </p:sp>
-      <p:sp>
-        <p:nvSpPr>
-          <p:cNvPr id="16" name="Text 14"/>
           <p:cNvSpPr/>
           <p:nvPr/>
         </p:nvSpPr>
@@ -12768,7 +12771,7 @@
       </p:sp>
       <p:sp>
         <p:nvSpPr>
-          <p:cNvPr id="17" name="Text 15"/>
+          <p:cNvPr id="16" name="Text 14"/>
           <p:cNvSpPr/>
           <p:nvPr/>
         </p:nvSpPr>
@@ -13726,16 +13729,16 @@
         <p:spPr>
           <a:xfrm>
             <a:off x="640080" y="1645920"/>
-            <a:ext cx="5486400" cy="822960"/>
-          </a:xfrm>
-          <a:prstGeom prst="rect">
-            <a:avLst/>
-          </a:prstGeom>
-          <a:noFill/>
-          <a:ln/>
-        </p:spPr>
-        <p:txBody>
-          <a:bodyPr wrap="square" lIns="0" tIns="0" rIns="0" bIns="0" rtlCol="0" anchor="t"/>
+            <a:ext cx="5486400" cy="502920"/>
+          </a:xfrm>
+          <a:prstGeom prst="rect">
+            <a:avLst/>
+          </a:prstGeom>
+          <a:noFill/>
+          <a:ln/>
+        </p:spPr>
+        <p:txBody>
+          <a:bodyPr wrap="square" lIns="0" tIns="0" rIns="0" bIns="0" rtlCol="0" anchor="ctr"/>
           <a:lstStyle/>
           <a:p>
             <a:pPr algn="l" indent="0" marL="0">
@@ -13753,27 +13756,7 @@
                 <a:ea typeface="Hiragino Sans" pitchFamily="34" charset="-122"/>
                 <a:cs typeface="Hiragino Sans" pitchFamily="34" charset="-120"/>
               </a:rPr>
-              <a:t>分割したコードは “ローカルサーバー” で開きます。</a:t>
-            </a:r>
-            <a:endParaRPr lang="en-US" sz="1500" dirty="0"/>
-          </a:p>
-          <a:p>
-            <a:pPr algn="l" indent="0" marL="0">
-              <a:lnSpc>
-                <a:spcPct val="130000"/>
-              </a:lnSpc>
-              <a:buNone/>
-            </a:pPr>
-            <a:r>
-              <a:rPr lang="en-US" sz="1500" dirty="0">
-                <a:solidFill>
-                  <a:srgbClr val="C9D1D9"/>
-                </a:solidFill>
-                <a:latin typeface="Hiragino Sans" pitchFamily="34" charset="0"/>
-                <a:ea typeface="Hiragino Sans" pitchFamily="34" charset="-122"/>
-                <a:cs typeface="Hiragino Sans" pitchFamily="34" charset="-120"/>
-              </a:rPr>
-              <a:t>（ダブルクリックでは動きません）</a:t>
+              <a:t>生成された index.html をブラウザで開いて、実際に操作します。</a:t>
             </a:r>
             <a:endParaRPr lang="en-US" sz="1500" dirty="0"/>
           </a:p>
@@ -14164,7 +14147,7 @@
                 <a:ea typeface="Hiragino Sans" pitchFamily="34" charset="-122"/>
                 <a:cs typeface="Hiragino Sans" pitchFamily="34" charset="-120"/>
               </a:rPr>
-              <a:t>「このフォルダをローカルサーバーで開いて」と言えば、起動まで任せられます。</a:t>
+              <a:t>「このフォルダをブラウザで開いて確認して」と言えば、確認まで任せられます。</a:t>
             </a:r>
             <a:endParaRPr lang="en-US" sz="1350" dirty="0"/>
           </a:p>
@@ -16027,7 +16010,7 @@
                 <a:ea typeface="Menlo" pitchFamily="34" charset="-122"/>
                 <a:cs typeface="Menlo" pitchFamily="34" charset="-120"/>
               </a:rPr>
-              <a:t>- アプリは複数ファイルに分けて作る</a:t>
+              <a:t>- 小さく動くものから作る</a:t>
             </a:r>
             <a:endParaRPr lang="en-US" sz="1300" dirty="0"/>
           </a:p>
@@ -16047,7 +16030,7 @@
                 <a:ea typeface="Menlo" pitchFamily="34" charset="-122"/>
                 <a:cs typeface="Menlo" pitchFamily="34" charset="-120"/>
               </a:rPr>
-              <a:t>- 凝った依存は入れない</a:t>
+              <a:t>- まずブラウザで動作確認する</a:t>
             </a:r>
             <a:endParaRPr lang="en-US" sz="1300" dirty="0"/>
           </a:p>
@@ -17495,7 +17478,7 @@
                 <a:ea typeface="Hiragino Sans" pitchFamily="34" charset="-122"/>
                 <a:cs typeface="Hiragino Sans" pitchFamily="34" charset="-120"/>
               </a:rPr>
-              <a:t>複数ファイルの ToDo アプリを作らせた</a:t>
+              <a:t>ToDo ミニアプリを作らせて確認した</a:t>
             </a:r>
             <a:endParaRPr lang="en-US" sz="1800" dirty="0"/>
           </a:p>

</xml_diff>